<commit_message>
Apresentação comercial: ritmo de fundos azul e branco
Azul na capa e nos pontos de atenção (custo de não agir e Visão 360);
branco nos slides de continuidade, com paleta, logo e gráfico ajustados.

Co-Authored-By: Claude Opus 5.5 <noreply@anthropic.com>
Claude-Session: https://claude.ai/code/session_019K4zAb3bJvz8CAJA5zYx7h
</commit_message>
<xml_diff>
--- a/apresentacoes/comercial-consultoria/Apresentacao Comercial - Desenvolve Consultoria.pptx
+++ b/apresentacoes/comercial-consultoria/Apresentacao Comercial - Desenvolve Consultoria.pptx
@@ -115,26 +115,26 @@
   <p:extLst>
     <p:ext uri="{521415D9-36F7-43E2-AB2F-B90AF26B5E84}">
       <p14:sectionLst xmlns:p14="http://schemas.microsoft.com/office/powerpoint/2010/main">
-        <p14:section name="Abertura" id="{63b32448-7faa-1542-a9e5-265b23eb84b1}">
+        <p14:section name="Abertura" id="{a9b26421-5fc8-bc1f-ecec-3da375c4a101}">
           <p14:sldIdLst>
             <p14:sldId id="256"/>
           </p14:sldIdLst>
         </p14:section>
-        <p14:section name="O desafio" id="{a019a51e-63b9-0962-1666-4de11d12027e}">
+        <p14:section name="O desafio" id="{085bd17b-7397-f39b-a11c-0e3284aabd98}">
           <p14:sldIdLst>
             <p14:sldId id="257"/>
             <p14:sldId id="258"/>
             <p14:sldId id="259"/>
           </p14:sldIdLst>
         </p14:section>
-        <p14:section name="A solução" id="{3209381e-f325-ae78-d056-409b61968fd0}">
+        <p14:section name="A solução" id="{8ddec474-5fad-81a7-5b7d-ee250fad4076}">
           <p14:sldIdLst>
             <p14:sldId id="260"/>
             <p14:sldId id="261"/>
             <p14:sldId id="262"/>
           </p14:sldIdLst>
         </p14:section>
-        <p14:section name="Fechamento" id="{72f83d93-4494-a6d9-5908-6aa6e057b4d8}">
+        <p14:section name="Fechamento" id="{c0196886-5a21-5b99-1f9b-50788fce6b64}">
           <p14:sldIdLst>
             <p14:sldId id="263"/>
             <p14:sldId id="264"/>
@@ -177,7 +177,7 @@
           </c:tx>
           <c:spPr>
             <a:solidFill>
-              <a:srgbClr val="5A6AA8"/>
+              <a:srgbClr val="A9B6DA"/>
             </a:solidFill>
             <a:effectLst/>
           </c:spPr>
@@ -191,7 +191,7 @@
                 <a:pPr>
                   <a:defRPr b="1" i="0" strike="noStrike" sz="1400" u="none">
                     <a:solidFill>
-                      <a:srgbClr val="FFFFFF"/>
+                      <a:srgbClr val="0D1150"/>
                     </a:solidFill>
                     <a:latin typeface="+mn-lt"/>
                   </a:defRPr>
@@ -212,7 +212,7 @@
             <c:bubble3D val="0"/>
             <c:spPr>
               <a:solidFill>
-                <a:srgbClr val="5A6AA8"/>
+                <a:srgbClr val="A9B6DA"/>
               </a:solidFill>
               <a:effectLst/>
             </c:spPr>
@@ -223,7 +223,7 @@
             <c:bubble3D val="0"/>
             <c:spPr>
               <a:solidFill>
-                <a:srgbClr val="00C2CB"/>
+                <a:srgbClr val="004AAD"/>
               </a:solidFill>
               <a:effectLst/>
             </c:spPr>
@@ -269,7 +269,7 @@
               <a:pPr>
                 <a:defRPr b="1" i="0" strike="noStrike" sz="1400" u="none">
                   <a:solidFill>
-                    <a:srgbClr val="FFFFFF"/>
+                    <a:srgbClr val="0D1150"/>
                   </a:solidFill>
                   <a:latin typeface="+mn-lt"/>
                 </a:defRPr>
@@ -315,7 +315,7 @@
             <a:pPr>
               <a:defRPr sz="1200" b="0" i="0" u="none" strike="noStrike">
                 <a:solidFill>
-                  <a:srgbClr val="B8C4EC"/>
+                  <a:srgbClr val="4A5578"/>
                 </a:solidFill>
                 <a:latin typeface="+mn-lt"/>
               </a:defRPr>
@@ -1628,11 +1628,267 @@
 
 <file path=ppt/slideLayouts/slideLayout3.xml><?xml version="1.0" encoding="utf-8"?>
 <p:sldLayout xmlns:a="http://schemas.openxmlformats.org/drawingml/2006/main" xmlns:r="http://schemas.openxmlformats.org/officeDocument/2006/relationships" xmlns:p="http://schemas.openxmlformats.org/presentationml/2006/main" preserve="1">
-  <p:cSld name="CONTEUDO">
+  <p:cSld name="AZUL">
+    <p:bg>
+      <p:bgPr>
+        <a:blipFill dpi="0" rotWithShape="1">
+          <a:blip r:embed="rId2">
+            <a:lum/>
+          </a:blip>
+          <a:srcRect/>
+          <a:stretch>
+            <a:fillRect/>
+          </a:stretch>
+        </a:blipFill>
+        <a:effectLst/>
+      </p:bgPr>
+    </p:bg>
+    <p:spTree>
+      <p:nvGrpSpPr>
+        <p:cNvPr id="1" name=""/>
+        <p:cNvGrpSpPr/>
+        <p:nvPr/>
+      </p:nvGrpSpPr>
+      <p:grpSpPr>
+        <a:xfrm>
+          <a:off x="0" y="0"/>
+          <a:ext cx="0" cy="0"/>
+          <a:chOff x="0" y="0"/>
+          <a:chExt cx="0" cy="0"/>
+        </a:xfrm>
+      </p:grpSpPr>
+      <p:sp>
+        <p:nvSpPr>
+          <p:cNvPr id="2" name="Shape 0"/>
+          <p:cNvSpPr/>
+          <p:nvPr/>
+        </p:nvSpPr>
+        <p:spPr>
+          <a:xfrm>
+            <a:off x="0" y="0"/>
+            <a:ext cx="12191695" cy="6858000"/>
+          </a:xfrm>
+          <a:prstGeom prst="rect">
+            <a:avLst/>
+          </a:prstGeom>
+          <a:solidFill>
+            <a:srgbClr val="0D1150">
+              <a:alpha val="88000"/>
+            </a:srgbClr>
+          </a:solidFill>
+          <a:ln/>
+        </p:spPr>
+      </p:sp>
+      <p:pic>
+        <p:nvPicPr>
+          <p:cNvPr id="3" name="Image 0" descr="/tmp/claude-0/-home-user/25c0be0f-0a5e-54d0-b86c-4757d56f039f/scratchpad/deck/assets/dsve-branco.png">    </p:cNvPr>
+          <p:cNvPicPr>
+            <a:picLocks noChangeAspect="1"/>
+          </p:cNvPicPr>
+          <p:nvPr/>
+        </p:nvPicPr>
+        <p:blipFill>
+          <a:blip r:embed="rId1"/>
+          <a:stretch>
+            <a:fillRect/>
+          </a:stretch>
+        </p:blipFill>
+        <p:spPr>
+          <a:xfrm>
+            <a:off x="548640" y="6327648"/>
+            <a:ext cx="877824" cy="320040"/>
+          </a:xfrm>
+          <a:prstGeom prst="rect">
+            <a:avLst/>
+          </a:prstGeom>
+        </p:spPr>
+      </p:pic>
+      <p:sp>
+        <p:nvSpPr>
+          <p:cNvPr id="4" name="Text 1"/>
+          <p:cNvSpPr/>
+          <p:nvPr/>
+        </p:nvSpPr>
+        <p:spPr>
+          <a:xfrm>
+            <a:off x="1600200" y="6355080"/>
+            <a:ext cx="5486400" cy="274320"/>
+          </a:xfrm>
+          <a:prstGeom prst="rect">
+            <a:avLst/>
+          </a:prstGeom>
+          <a:noFill/>
+          <a:ln/>
+        </p:spPr>
+        <p:txBody>
+          <a:bodyPr wrap="square" lIns="0" tIns="0" rIns="0" bIns="0" rtlCol="0" anchor="ctr"/>
+          <a:lstStyle/>
+          <a:p>
+            <a:pPr indent="0" marL="0">
+              <a:buNone/>
+            </a:pPr>
+            <a:r>
+              <a:rPr lang="en-US" sz="1000" dirty="0">
+                <a:solidFill>
+                  <a:srgbClr val="B8C4EC"/>
+                </a:solidFill>
+                <a:latin typeface="Montserrat" pitchFamily="34" charset="0"/>
+                <a:ea typeface="Montserrat" pitchFamily="34" charset="-122"/>
+                <a:cs typeface="Montserrat" pitchFamily="34" charset="-120"/>
+              </a:rPr>
+              <a:t>Desenvolve Consultoria · Grupo Desenvolve</a:t>
+            </a:r>
+            <a:endParaRPr lang="en-US" sz="1000" dirty="0"/>
+          </a:p>
+        </p:txBody>
+      </p:sp>
+      <p:sp>
+        <p:nvSpPr>
+          <p:cNvPr id="5" name="Text 2"/>
+          <p:cNvSpPr/>
+          <p:nvPr>
+            <p:ph idx="103" type="body" hasCustomPrompt="1"/>
+          </p:nvPr>
+        </p:nvSpPr>
+        <p:spPr>
+          <a:xfrm>
+            <a:off x="548640" y="411480"/>
+            <a:ext cx="10972800" cy="292608"/>
+          </a:xfrm>
+          <a:prstGeom prst="rect">
+            <a:avLst/>
+          </a:prstGeom>
+          <a:noFill/>
+          <a:ln/>
+        </p:spPr>
+        <p:txBody>
+          <a:bodyPr wrap="square" rtlCol="0"/>
+          <a:lstStyle>
+            <a:lvl1pPr indent="0" marL="0">
+              <a:buNone/>
+              <a:defRPr lang="en-US" sz="1200" b="1" spc="400" kern="0" dirty="0">
+                <a:solidFill>
+                  <a:srgbClr val="00C2CB"/>
+                </a:solidFill>
+                <a:latin typeface="Montserrat" pitchFamily="34" charset="0"/>
+                <a:ea typeface="Montserrat" pitchFamily="34" charset="-122"/>
+                <a:cs typeface="Montserrat" pitchFamily="34" charset="-120"/>
+              </a:defRPr>
+            </a:lvl1pPr>
+          </a:lstStyle>
+          <a:p>
+            <a:pPr indent="0" marL="0">
+              <a:buNone/>
+            </a:pPr>
+            <a:endParaRPr lang="en-US" sz="1200" dirty="0"/>
+          </a:p>
+        </p:txBody>
+      </p:sp>
+      <p:sp>
+        <p:nvSpPr>
+          <p:cNvPr id="6" name="Text 2"/>
+          <p:cNvSpPr/>
+          <p:nvPr>
+            <p:ph idx="104" type="title" hasCustomPrompt="1"/>
+          </p:nvPr>
+        </p:nvSpPr>
+        <p:spPr>
+          <a:xfrm>
+            <a:off x="548640" y="731520"/>
+            <a:ext cx="11064240" cy="1005840"/>
+          </a:xfrm>
+          <a:prstGeom prst="rect">
+            <a:avLst/>
+          </a:prstGeom>
+          <a:noFill/>
+          <a:ln/>
+        </p:spPr>
+        <p:txBody>
+          <a:bodyPr wrap="square" rtlCol="0"/>
+          <a:lstStyle>
+            <a:lvl1pPr algn="l" indent="0" marL="0">
+              <a:buNone/>
+              <a:defRPr lang="en-US" sz="3000" dirty="0">
+                <a:solidFill>
+                  <a:srgbClr val="FFFFFF"/>
+                </a:solidFill>
+                <a:latin typeface="Raleway" pitchFamily="34" charset="0"/>
+                <a:ea typeface="Raleway" pitchFamily="34" charset="-122"/>
+                <a:cs typeface="Raleway" pitchFamily="34" charset="-120"/>
+              </a:defRPr>
+            </a:lvl1pPr>
+          </a:lstStyle>
+          <a:p>
+            <a:pPr algn="l" indent="0" marL="0">
+              <a:buNone/>
+            </a:pPr>
+            <a:endParaRPr lang="en-US" sz="3000" dirty="0"/>
+          </a:p>
+        </p:txBody>
+      </p:sp>
+      <p:sp>
+        <p:nvSpPr>
+          <p:cNvPr id="25" name="Slide Number Placeholder 0"/>
+          <p:cNvSpPr>
+            <a:spLocks noGrp="1"/>
+          </p:cNvSpPr>
+          <p:nvPr>
+            <p:ph type="sldNum" sz="quarter" idx="4294967295"/>
+          </p:nvPr>
+        </p:nvSpPr>
+        <p:spPr>
+          <a:xfrm>
+            <a:off x="11155680" y="6355080"/>
+            <a:ext cx="502920" cy="274320"/>
+          </a:xfrm>
+          <a:prstGeom prst="rect">
+            <a:avLst/>
+          </a:prstGeom>
+          <a:extLst>
+            <a:ext uri="{C572A759-6A51-4108-AA02-DFA0A04FC94B}">
+              <ma14:wrappingTextBoxFlag xmlns:ma14="http://schemas.microsoft.com/office/mac/drawingml/2011/main" val="0"/>
+            </a:ext>
+          </a:extLst>
+        </p:spPr>
+        <p:txBody>
+          <a:bodyPr/>
+          <a:lstStyle>
+            <a:lvl1pPr>
+              <a:defRPr sz="1000">
+                <a:solidFill>
+                  <a:srgbClr val="B8C4EC"/>
+                </a:solidFill>
+                <a:latin typeface="Montserrat"/>
+                <a:ea typeface="Montserrat"/>
+                <a:cs typeface="Montserrat"/>
+              </a:defRPr>
+            </a:lvl1pPr>
+          </a:lstStyle>
+          <a:p>
+            <a:pPr algn="r"/>
+            <a:fld id="{F7021451-1387-4CA6-816F-3879F97B5CBC}" type="slidenum">
+              <a:rPr b="0" lang="en-US"/>
+              <a:t>1003</a:t>
+            </a:fld>
+            <a:endParaRPr lang="en-US"/>
+          </a:p>
+        </p:txBody>
+      </p:sp>
+    </p:spTree>
+  </p:cSld>
+  <p:clrMapOvr>
+    <a:masterClrMapping/>
+  </p:clrMapOvr>
+</p:sldLayout>
+</file>
+
+<file path=ppt/slideLayouts/slideLayout4.xml><?xml version="1.0" encoding="utf-8"?>
+<p:sldLayout xmlns:a="http://schemas.openxmlformats.org/drawingml/2006/main" xmlns:r="http://schemas.openxmlformats.org/officeDocument/2006/relationships" xmlns:p="http://schemas.openxmlformats.org/presentationml/2006/main" preserve="1">
+  <p:cSld name="BRANCO">
     <p:bg>
       <p:bgPr>
         <a:solidFill>
-          <a:srgbClr val="0D1150"/>
+          <a:srgbClr val="FFFFFF"/>
         </a:solidFill>
       </p:bgPr>
     </p:bg>
@@ -1652,7 +1908,7 @@
       </p:grpSpPr>
       <p:pic>
         <p:nvPicPr>
-          <p:cNvPr id="2" name="Image 0" descr="/tmp/claude-0/-home-user/25c0be0f-0a5e-54d0-b86c-4757d56f039f/scratchpad/deck/assets/dsve-branco.png">    </p:cNvPr>
+          <p:cNvPr id="2" name="Image 0" descr="/tmp/claude-0/-home-user/25c0be0f-0a5e-54d0-b86c-4757d56f039f/scratchpad/deck/assets/dsve-azul.png">    </p:cNvPr>
           <p:cNvPicPr>
             <a:picLocks noChangeAspect="1"/>
           </p:cNvPicPr>
@@ -1701,7 +1957,7 @@
             <a:r>
               <a:rPr lang="en-US" sz="1000" dirty="0">
                 <a:solidFill>
-                  <a:srgbClr val="B8C4EC"/>
+                  <a:srgbClr val="4A5578"/>
                 </a:solidFill>
                 <a:latin typeface="Montserrat" pitchFamily="34" charset="0"/>
                 <a:ea typeface="Montserrat" pitchFamily="34" charset="-122"/>
@@ -1739,7 +1995,7 @@
               <a:buNone/>
               <a:defRPr lang="en-US" sz="1200" b="1" spc="400" kern="0" dirty="0">
                 <a:solidFill>
-                  <a:schemeClr val="accent1"/>
+                  <a:srgbClr val="004AAD"/>
                 </a:solidFill>
                 <a:latin typeface="Montserrat" pitchFamily="34" charset="0"/>
                 <a:ea typeface="Montserrat" pitchFamily="34" charset="-122"/>
@@ -1781,7 +2037,7 @@
               <a:buNone/>
               <a:defRPr lang="en-US" sz="3000" dirty="0">
                 <a:solidFill>
-                  <a:schemeClr val="bg1"/>
+                  <a:srgbClr val="0D1150"/>
                 </a:solidFill>
                 <a:latin typeface="Raleway" pitchFamily="34" charset="0"/>
                 <a:ea typeface="Raleway" pitchFamily="34" charset="-122"/>
@@ -1827,7 +2083,7 @@
             <a:lvl1pPr>
               <a:defRPr sz="1000">
                 <a:solidFill>
-                  <a:srgbClr val="B8C4EC"/>
+                  <a:srgbClr val="4A5578"/>
                 </a:solidFill>
                 <a:latin typeface="Montserrat"/>
                 <a:ea typeface="Montserrat"/>
@@ -1839,7 +2095,7 @@
             <a:pPr algn="r"/>
             <a:fld id="{F7021451-1387-4CA6-816F-3879F97B5CBC}" type="slidenum">
               <a:rPr b="0" lang="en-US"/>
-              <a:t>1003</a:t>
+              <a:t>1004</a:t>
             </a:fld>
             <a:endParaRPr lang="en-US"/>
           </a:p>
@@ -1925,6 +2181,7 @@
     <p:sldLayoutId id="2147483649" r:id="rId1"/>
     <p:sldLayoutId id="2147483650" r:id="rId2"/>
     <p:sldLayoutId id="2147483651" r:id="rId3"/>
+    <p:sldLayoutId id="2147483652" r:id="rId4"/>
   </p:sldLayoutIdLst>
   <p:hf sldNum="0" hdr="0" ftr="0" dt="0"/>
   <p:txStyles>
@@ -2206,9 +2463,7 @@
           <p:nvPr/>
         </p:nvPicPr>
         <p:blipFill>
-          <a:blip r:embed="rId1">
-            <a:alphaModFix amt="90000"/>
-          </a:blip>
+          <a:blip r:embed="rId1"/>
           <a:stretch>
             <a:fillRect/>
           </a:stretch>
@@ -2500,7 +2755,7 @@
             <a:r>
               <a:rPr lang="en-US" sz="1200" b="1" spc="400" kern="0" dirty="0">
                 <a:solidFill>
-                  <a:schemeClr val="accent1"/>
+                  <a:srgbClr val="004AAD"/>
                 </a:solidFill>
                 <a:latin typeface="Montserrat" pitchFamily="34" charset="0"/>
                 <a:ea typeface="Montserrat" pitchFamily="34" charset="-122"/>
@@ -2541,7 +2796,7 @@
             <a:r>
               <a:rPr lang="en-US" sz="3000" dirty="0">
                 <a:solidFill>
-                  <a:schemeClr val="bg1"/>
+                  <a:srgbClr val="0D1150"/>
                 </a:solidFill>
                 <a:latin typeface="Raleway" pitchFamily="34" charset="0"/>
                 <a:ea typeface="Raleway" pitchFamily="34" charset="-122"/>
@@ -2555,7 +2810,7 @@
             <a:r>
               <a:rPr lang="en-US" sz="3000" b="1" dirty="0">
                 <a:solidFill>
-                  <a:srgbClr val="00C2CB"/>
+                  <a:srgbClr val="004AAD"/>
                 </a:solidFill>
                 <a:latin typeface="Raleway" pitchFamily="34" charset="0"/>
                 <a:ea typeface="Raleway" pitchFamily="34" charset="-122"/>
@@ -2584,11 +2839,11 @@
             </a:avLst>
           </a:prstGeom>
           <a:solidFill>
-            <a:srgbClr val="151A6B"/>
+            <a:srgbClr val="004AAD"/>
           </a:solidFill>
           <a:ln w="12700">
             <a:solidFill>
-              <a:srgbClr val="2A3290"/>
+              <a:srgbClr val="004AAD"/>
             </a:solidFill>
             <a:prstDash val="solid"/>
           </a:ln>
@@ -2602,8 +2857,8 @@
         </p:nvSpPr>
         <p:spPr>
           <a:xfrm>
-            <a:off x="868680" y="2194560"/>
-            <a:ext cx="4754880" cy="914400"/>
+            <a:off x="914400" y="2240280"/>
+            <a:ext cx="4663440" cy="914400"/>
           </a:xfrm>
           <a:prstGeom prst="rect">
             <a:avLst/>
@@ -2655,17 +2910,17 @@
         </p:nvSpPr>
         <p:spPr>
           <a:xfrm>
-            <a:off x="868680" y="3108960"/>
-            <a:ext cx="4754880" cy="365760"/>
-          </a:xfrm>
-          <a:prstGeom prst="rect">
-            <a:avLst/>
-          </a:prstGeom>
-          <a:noFill/>
-          <a:ln/>
-        </p:spPr>
-        <p:txBody>
-          <a:bodyPr wrap="square" lIns="0" tIns="0" rIns="0" bIns="0" rtlCol="0" anchor="ctr"/>
+            <a:off x="914400" y="3154680"/>
+            <a:ext cx="4663440" cy="594360"/>
+          </a:xfrm>
+          <a:prstGeom prst="rect">
+            <a:avLst/>
+          </a:prstGeom>
+          <a:noFill/>
+          <a:ln/>
+        </p:spPr>
+        <p:txBody>
+          <a:bodyPr wrap="square" lIns="0" tIns="0" rIns="0" bIns="0" rtlCol="0" anchor="t"/>
           <a:lstStyle/>
           <a:p>
             <a:pPr indent="0" marL="0">
@@ -2691,8 +2946,8 @@
         </p:nvSpPr>
         <p:spPr>
           <a:xfrm>
-            <a:off x="868680" y="3611880"/>
-            <a:ext cx="4709160" cy="1737360"/>
+            <a:off x="914400" y="3794760"/>
+            <a:ext cx="4617720" cy="1645920"/>
           </a:xfrm>
           <a:prstGeom prst="rect">
             <a:avLst/>
@@ -2705,15 +2960,12 @@
           <a:lstStyle/>
           <a:p>
             <a:pPr indent="0" marL="0">
-              <a:spcAft>
-                <a:spcPts val="400"/>
-              </a:spcAft>
               <a:buNone/>
             </a:pPr>
             <a:r>
               <a:rPr lang="en-US" sz="1400" dirty="0">
                 <a:solidFill>
-                  <a:srgbClr val="B8C4EC"/>
+                  <a:srgbClr val="DCE6FA"/>
                 </a:solidFill>
               </a:rPr>
               <a:t>O recurso federal e estadual chega vinculado a blocos e finalidades definidos fora do município, que nem sempre atendem às necessidades locais. Enquanto ele se acumula em conta, o recurso próprio é pressionado a cobrir o restante.</a:t>
@@ -2730,8 +2982,8 @@
         </p:nvSpPr>
         <p:spPr>
           <a:xfrm>
-            <a:off x="868680" y="5532120"/>
-            <a:ext cx="4754880" cy="320040"/>
+            <a:off x="914400" y="5532120"/>
+            <a:ext cx="4663440" cy="320040"/>
           </a:xfrm>
           <a:prstGeom prst="rect">
             <a:avLst/>
@@ -2749,7 +3001,7 @@
             <a:r>
               <a:rPr lang="en-US" sz="1000" dirty="0">
                 <a:solidFill>
-                  <a:srgbClr val="B8C4EC"/>
+                  <a:srgbClr val="C9D7F5"/>
                 </a:solidFill>
               </a:rPr>
               <a:t>Fonte: InvestSUS, Painel de Saldos, Ministério da Saúde (consulta em out/2026).</a:t>
@@ -2775,11 +3027,11 @@
             </a:avLst>
           </a:prstGeom>
           <a:solidFill>
-            <a:srgbClr val="151A6B"/>
+            <a:srgbClr val="EEF2FB"/>
           </a:solidFill>
           <a:ln w="12700">
             <a:solidFill>
-              <a:srgbClr val="2A3290"/>
+              <a:srgbClr val="D9E1F2"/>
             </a:solidFill>
             <a:prstDash val="solid"/>
           </a:ln>
@@ -2812,7 +3064,7 @@
             <a:r>
               <a:rPr lang="en-US" sz="1500" b="1" dirty="0">
                 <a:solidFill>
-                  <a:srgbClr val="FFFFFF"/>
+                  <a:srgbClr val="0D1150"/>
                 </a:solidFill>
               </a:rPr>
               <a:t>Receita própria aplicada em saúde pelos municípios, 2025</a:t>
@@ -2864,7 +3116,7 @@
             <a:r>
               <a:rPr lang="en-US" sz="1600" b="1" dirty="0">
                 <a:solidFill>
-                  <a:srgbClr val="00C2CB"/>
+                  <a:srgbClr val="004AAD"/>
                 </a:solidFill>
               </a:rPr>
               <a:t>R$ 57,4 bilhões</a:t>
@@ -2875,7 +3127,7 @@
             <a:r>
               <a:rPr lang="en-US" sz="1600" dirty="0">
                 <a:solidFill>
-                  <a:srgbClr val="FFFFFF"/>
+                  <a:srgbClr val="0D1150"/>
                 </a:solidFill>
               </a:rPr>
               <a:t> acima do piso constitucional, aplicados pelos municípios em 2024</a:t>
@@ -2911,7 +3163,7 @@
             <a:r>
               <a:rPr lang="en-US" sz="1000" dirty="0">
                 <a:solidFill>
-                  <a:srgbClr val="B8C4EC"/>
+                  <a:srgbClr val="4A5578"/>
                 </a:solidFill>
               </a:rPr>
               <a:t>Fonte: CNM, a partir de dados do SIOPS (2024 e 2025).</a:t>
@@ -2950,7 +3202,7 @@
             <a:lvl1pPr>
               <a:defRPr sz="1000">
                 <a:solidFill>
-                  <a:srgbClr val="B8C4EC"/>
+                  <a:srgbClr val="4A5578"/>
                 </a:solidFill>
                 <a:latin typeface="Montserrat"/>
                 <a:ea typeface="Montserrat"/>
@@ -3022,7 +3274,7 @@
             <a:r>
               <a:rPr lang="en-US" sz="1200" b="1" spc="400" kern="0" dirty="0">
                 <a:solidFill>
-                  <a:schemeClr val="accent1"/>
+                  <a:srgbClr val="004AAD"/>
                 </a:solidFill>
                 <a:latin typeface="Montserrat" pitchFamily="34" charset="0"/>
                 <a:ea typeface="Montserrat" pitchFamily="34" charset="-122"/>
@@ -3063,7 +3315,7 @@
             <a:r>
               <a:rPr lang="en-US" sz="3000" dirty="0">
                 <a:solidFill>
-                  <a:schemeClr val="bg1"/>
+                  <a:srgbClr val="0D1150"/>
                 </a:solidFill>
                 <a:latin typeface="Raleway" pitchFamily="34" charset="0"/>
                 <a:ea typeface="Raleway" pitchFamily="34" charset="-122"/>
@@ -3077,7 +3329,7 @@
             <a:r>
               <a:rPr lang="en-US" sz="3000" b="1" dirty="0">
                 <a:solidFill>
-                  <a:srgbClr val="00C2CB"/>
+                  <a:srgbClr val="004AAD"/>
                 </a:solidFill>
                 <a:latin typeface="Raleway" pitchFamily="34" charset="0"/>
                 <a:ea typeface="Raleway" pitchFamily="34" charset="-122"/>
@@ -3116,7 +3368,7 @@
             <a:r>
               <a:rPr lang="en-US" sz="1800" b="1" dirty="0">
                 <a:solidFill>
-                  <a:srgbClr val="00C2CB"/>
+                  <a:srgbClr val="004AAD"/>
                 </a:solidFill>
               </a:rPr>
               <a:t>A pressão sobre a gestão</a:t>
@@ -3140,11 +3392,11 @@
             <a:avLst/>
           </a:prstGeom>
           <a:solidFill>
-            <a:srgbClr val="00C2CB"/>
+            <a:srgbClr val="004AAD"/>
           </a:solidFill>
           <a:ln w="12700">
             <a:solidFill>
-              <a:srgbClr val="00C2CB"/>
+              <a:srgbClr val="004AAD"/>
             </a:solidFill>
             <a:prstDash val="solid"/>
           </a:ln>
@@ -3201,7 +3453,7 @@
             <a:r>
               <a:rPr lang="en-US" sz="1500" dirty="0">
                 <a:solidFill>
-                  <a:srgbClr val="FFFFFF"/>
+                  <a:srgbClr val="0D1150"/>
                 </a:solidFill>
               </a:rPr>
               <a:t>Processos licitatórios e montagem de documentos</a:t>
@@ -3225,11 +3477,11 @@
             <a:avLst/>
           </a:prstGeom>
           <a:solidFill>
-            <a:srgbClr val="00C2CB"/>
+            <a:srgbClr val="004AAD"/>
           </a:solidFill>
           <a:ln w="12700">
             <a:solidFill>
-              <a:srgbClr val="00C2CB"/>
+              <a:srgbClr val="004AAD"/>
             </a:solidFill>
             <a:prstDash val="solid"/>
           </a:ln>
@@ -3286,7 +3538,7 @@
             <a:r>
               <a:rPr lang="en-US" sz="1500" dirty="0">
                 <a:solidFill>
-                  <a:srgbClr val="FFFFFF"/>
+                  <a:srgbClr val="0D1150"/>
                 </a:solidFill>
               </a:rPr>
               <a:t>Respostas e ofícios a Tribunais de Contas e Ministério Público</a:t>
@@ -3310,11 +3562,11 @@
             <a:avLst/>
           </a:prstGeom>
           <a:solidFill>
-            <a:srgbClr val="00C2CB"/>
+            <a:srgbClr val="004AAD"/>
           </a:solidFill>
           <a:ln w="12700">
             <a:solidFill>
-              <a:srgbClr val="00C2CB"/>
+              <a:srgbClr val="004AAD"/>
             </a:solidFill>
             <a:prstDash val="solid"/>
           </a:ln>
@@ -3371,7 +3623,7 @@
             <a:r>
               <a:rPr lang="en-US" sz="1500" dirty="0">
                 <a:solidFill>
-                  <a:srgbClr val="FFFFFF"/>
+                  <a:srgbClr val="0D1150"/>
                 </a:solidFill>
               </a:rPr>
               <a:t>Responsabilidade pessoal por atos da Secretaria que nem sempre consegue acompanhar</a:t>
@@ -3395,11 +3647,11 @@
             <a:avLst/>
           </a:prstGeom>
           <a:solidFill>
-            <a:srgbClr val="00C2CB"/>
+            <a:srgbClr val="004AAD"/>
           </a:solidFill>
           <a:ln w="12700">
             <a:solidFill>
-              <a:srgbClr val="00C2CB"/>
+              <a:srgbClr val="004AAD"/>
             </a:solidFill>
             <a:prstDash val="solid"/>
           </a:ln>
@@ -3456,7 +3708,7 @@
             <a:r>
               <a:rPr lang="en-US" sz="1500" dirty="0">
                 <a:solidFill>
-                  <a:srgbClr val="FFFFFF"/>
+                  <a:srgbClr val="0D1150"/>
                 </a:solidFill>
               </a:rPr>
               <a:t>Regras e portarias que mudam a todo momento</a:t>
@@ -3482,11 +3734,11 @@
             </a:avLst>
           </a:prstGeom>
           <a:solidFill>
-            <a:srgbClr val="151A6B"/>
+            <a:srgbClr val="EEF2FB"/>
           </a:solidFill>
           <a:ln w="12700">
             <a:solidFill>
-              <a:srgbClr val="2A3290"/>
+              <a:srgbClr val="D9E1F2"/>
             </a:solidFill>
             <a:prstDash val="solid"/>
           </a:ln>
@@ -3519,7 +3771,7 @@
             <a:r>
               <a:rPr lang="en-US" sz="1800" b="1" dirty="0">
                 <a:solidFill>
-                  <a:srgbClr val="FFFFFF"/>
+                  <a:srgbClr val="0D1150"/>
                 </a:solidFill>
               </a:rPr>
               <a:t>Quais destes suportes a sua Secretaria tem hoje?</a:t>
@@ -3545,11 +3797,11 @@
             </a:avLst>
           </a:prstGeom>
           <a:solidFill>
-            <a:srgbClr val="0D1150"/>
+            <a:srgbClr val="FFFFFF"/>
           </a:solidFill>
           <a:ln w="19050">
             <a:solidFill>
-              <a:srgbClr val="00C2CB"/>
+              <a:srgbClr val="004AAD"/>
             </a:solidFill>
             <a:prstDash val="solid"/>
           </a:ln>
@@ -3582,7 +3834,7 @@
             <a:r>
               <a:rPr lang="en-US" sz="1600" dirty="0">
                 <a:solidFill>
-                  <a:srgbClr val="FFFFFF"/>
+                  <a:srgbClr val="0D1150"/>
                 </a:solidFill>
               </a:rPr>
               <a:t>Jurídico-sanitário</a:t>
@@ -3608,11 +3860,11 @@
             </a:avLst>
           </a:prstGeom>
           <a:solidFill>
-            <a:srgbClr val="0D1150"/>
+            <a:srgbClr val="FFFFFF"/>
           </a:solidFill>
           <a:ln w="19050">
             <a:solidFill>
-              <a:srgbClr val="00C2CB"/>
+              <a:srgbClr val="004AAD"/>
             </a:solidFill>
             <a:prstDash val="solid"/>
           </a:ln>
@@ -3645,7 +3897,7 @@
             <a:r>
               <a:rPr lang="en-US" sz="1600" dirty="0">
                 <a:solidFill>
-                  <a:srgbClr val="FFFFFF"/>
+                  <a:srgbClr val="0D1150"/>
                 </a:solidFill>
               </a:rPr>
               <a:t>Financeiro e orçamentário</a:t>
@@ -3671,11 +3923,11 @@
             </a:avLst>
           </a:prstGeom>
           <a:solidFill>
-            <a:srgbClr val="0D1150"/>
+            <a:srgbClr val="FFFFFF"/>
           </a:solidFill>
           <a:ln w="19050">
             <a:solidFill>
-              <a:srgbClr val="00C2CB"/>
+              <a:srgbClr val="004AAD"/>
             </a:solidFill>
             <a:prstDash val="solid"/>
           </a:ln>
@@ -3708,7 +3960,7 @@
             <a:r>
               <a:rPr lang="en-US" sz="1600" dirty="0">
                 <a:solidFill>
-                  <a:srgbClr val="FFFFFF"/>
+                  <a:srgbClr val="0D1150"/>
                 </a:solidFill>
               </a:rPr>
               <a:t>Técnico e de faturamento</a:t>
@@ -3734,11 +3986,11 @@
             </a:avLst>
           </a:prstGeom>
           <a:solidFill>
-            <a:srgbClr val="0D1150"/>
+            <a:srgbClr val="FFFFFF"/>
           </a:solidFill>
           <a:ln w="19050">
             <a:solidFill>
-              <a:srgbClr val="00C2CB"/>
+              <a:srgbClr val="004AAD"/>
             </a:solidFill>
             <a:prstDash val="solid"/>
           </a:ln>
@@ -3771,7 +4023,7 @@
             <a:r>
               <a:rPr lang="en-US" sz="1600" dirty="0">
                 <a:solidFill>
-                  <a:srgbClr val="FFFFFF"/>
+                  <a:srgbClr val="0D1150"/>
                 </a:solidFill>
               </a:rPr>
               <a:t>Sistemas do Ministério da Saúde</a:t>
@@ -3797,11 +4049,11 @@
             </a:avLst>
           </a:prstGeom>
           <a:solidFill>
-            <a:srgbClr val="0D1150"/>
+            <a:srgbClr val="FFFFFF"/>
           </a:solidFill>
           <a:ln w="19050">
             <a:solidFill>
-              <a:srgbClr val="00C2CB"/>
+              <a:srgbClr val="004AAD"/>
             </a:solidFill>
             <a:prstDash val="solid"/>
           </a:ln>
@@ -3834,7 +4086,7 @@
             <a:r>
               <a:rPr lang="en-US" sz="1600" dirty="0">
                 <a:solidFill>
-                  <a:srgbClr val="FFFFFF"/>
+                  <a:srgbClr val="0D1150"/>
                 </a:solidFill>
               </a:rPr>
               <a:t>Sistemas estaduais</a:t>
@@ -3868,9 +4120,9 @@
               <a:buNone/>
             </a:pPr>
             <a:r>
-              <a:rPr lang="en-US" sz="1400" i="1" dirty="0">
-                <a:solidFill>
-                  <a:srgbClr val="00C2CB"/>
+              <a:rPr lang="en-US" sz="1400" b="1" i="1" dirty="0">
+                <a:solidFill>
+                  <a:srgbClr val="004AAD"/>
                 </a:solidFill>
               </a:rPr>
               <a:t>Cada suporte que falta é um ponto de risco para a gestão e para o gestor.</a:t>
@@ -3909,7 +4161,7 @@
             <a:lvl1pPr>
               <a:defRPr sz="1000">
                 <a:solidFill>
-                  <a:srgbClr val="B8C4EC"/>
+                  <a:srgbClr val="4A5578"/>
                 </a:solidFill>
                 <a:latin typeface="Montserrat"/>
                 <a:ea typeface="Montserrat"/>
@@ -3954,10 +4206,10 @@
       </p:grpSpPr>
       <p:sp>
         <p:nvSpPr>
-          <p:cNvPr id="2" name="Text 1"/>
+          <p:cNvPr id="2" name="Text 2"/>
           <p:cNvSpPr/>
           <p:nvPr>
-            <p:ph idx="102" type="body" hasCustomPrompt="1"/>
+            <p:ph idx="103" type="body" hasCustomPrompt="1"/>
           </p:nvPr>
         </p:nvSpPr>
         <p:spPr>
@@ -3981,7 +4233,7 @@
             <a:r>
               <a:rPr lang="en-US" sz="1200" b="1" spc="400" kern="0" dirty="0">
                 <a:solidFill>
-                  <a:schemeClr val="accent1"/>
+                  <a:srgbClr val="00C2CB"/>
                 </a:solidFill>
                 <a:latin typeface="Montserrat" pitchFamily="34" charset="0"/>
                 <a:ea typeface="Montserrat" pitchFamily="34" charset="-122"/>
@@ -3995,10 +4247,10 @@
       </p:sp>
       <p:sp>
         <p:nvSpPr>
-          <p:cNvPr id="3" name="Text 1"/>
+          <p:cNvPr id="3" name="Text 2"/>
           <p:cNvSpPr/>
           <p:nvPr>
-            <p:ph idx="103" type="title" hasCustomPrompt="1"/>
+            <p:ph idx="104" type="title" hasCustomPrompt="1"/>
           </p:nvPr>
         </p:nvSpPr>
         <p:spPr>
@@ -4022,7 +4274,7 @@
             <a:r>
               <a:rPr lang="en-US" sz="3000" dirty="0">
                 <a:solidFill>
-                  <a:schemeClr val="bg1"/>
+                  <a:srgbClr val="FFFFFF"/>
                 </a:solidFill>
                 <a:latin typeface="Raleway" pitchFamily="34" charset="0"/>
                 <a:ea typeface="Raleway" pitchFamily="34" charset="-122"/>
@@ -4065,11 +4317,13 @@
             </a:avLst>
           </a:prstGeom>
           <a:solidFill>
-            <a:srgbClr val="151A6B"/>
+            <a:srgbClr val="0D1150">
+              <a:alpha val="90000"/>
+            </a:srgbClr>
           </a:solidFill>
           <a:ln w="12700">
             <a:solidFill>
-              <a:srgbClr val="2A3290"/>
+              <a:srgbClr val="3A4AA8"/>
             </a:solidFill>
             <a:prstDash val="solid"/>
           </a:ln>
@@ -4213,11 +4467,13 @@
             </a:avLst>
           </a:prstGeom>
           <a:solidFill>
-            <a:srgbClr val="151A6B"/>
+            <a:srgbClr val="0D1150">
+              <a:alpha val="90000"/>
+            </a:srgbClr>
           </a:solidFill>
           <a:ln w="12700">
             <a:solidFill>
-              <a:srgbClr val="2A3290"/>
+              <a:srgbClr val="3A4AA8"/>
             </a:solidFill>
             <a:prstDash val="solid"/>
           </a:ln>
@@ -4361,11 +4617,13 @@
             </a:avLst>
           </a:prstGeom>
           <a:solidFill>
-            <a:srgbClr val="151A6B"/>
+            <a:srgbClr val="0D1150">
+              <a:alpha val="90000"/>
+            </a:srgbClr>
           </a:solidFill>
           <a:ln w="12700">
             <a:solidFill>
-              <a:srgbClr val="2A3290"/>
+              <a:srgbClr val="3A4AA8"/>
             </a:solidFill>
             <a:prstDash val="solid"/>
           </a:ln>
@@ -4509,11 +4767,13 @@
             </a:avLst>
           </a:prstGeom>
           <a:solidFill>
-            <a:srgbClr val="151A6B"/>
+            <a:srgbClr val="0D1150">
+              <a:alpha val="90000"/>
+            </a:srgbClr>
           </a:solidFill>
           <a:ln w="12700">
             <a:solidFill>
-              <a:srgbClr val="2A3290"/>
+              <a:srgbClr val="3A4AA8"/>
             </a:solidFill>
             <a:prstDash val="solid"/>
           </a:ln>
@@ -4778,7 +5038,7 @@
             <a:r>
               <a:rPr lang="en-US" sz="1200" b="1" spc="400" kern="0" dirty="0">
                 <a:solidFill>
-                  <a:schemeClr val="accent1"/>
+                  <a:srgbClr val="004AAD"/>
                 </a:solidFill>
                 <a:latin typeface="Montserrat" pitchFamily="34" charset="0"/>
                 <a:ea typeface="Montserrat" pitchFamily="34" charset="-122"/>
@@ -4819,7 +5079,7 @@
             <a:r>
               <a:rPr lang="en-US" sz="3000" dirty="0">
                 <a:solidFill>
-                  <a:schemeClr val="bg1"/>
+                  <a:srgbClr val="0D1150"/>
                 </a:solidFill>
                 <a:latin typeface="Raleway" pitchFamily="34" charset="0"/>
                 <a:ea typeface="Raleway" pitchFamily="34" charset="-122"/>
@@ -4833,7 +5093,7 @@
             <a:r>
               <a:rPr lang="en-US" sz="3000" b="1" dirty="0">
                 <a:solidFill>
-                  <a:srgbClr val="00C2CB"/>
+                  <a:srgbClr val="004AAD"/>
                 </a:solidFill>
                 <a:latin typeface="Raleway" pitchFamily="34" charset="0"/>
                 <a:ea typeface="Raleway" pitchFamily="34" charset="-122"/>
@@ -4872,7 +5132,7 @@
             <a:r>
               <a:rPr lang="en-US" sz="1600" dirty="0">
                 <a:solidFill>
-                  <a:srgbClr val="B8C4EC"/>
+                  <a:srgbClr val="4A5578"/>
                 </a:solidFill>
               </a:rPr>
               <a:t>A Desenvolve Consultoria apoia Secretarias Municipais de Saúde no planejamento, no financiamento e no cumprimento das exigências do SUS. Faz parte do Grupo Desenvolve, que reúne consultoria, formação e tecnologia em saúde pública.</a:t>
@@ -4908,7 +5168,7 @@
             <a:r>
               <a:rPr lang="en-US" sz="4800" b="1" dirty="0">
                 <a:solidFill>
-                  <a:srgbClr val="00C2CB"/>
+                  <a:srgbClr val="004AAD"/>
                 </a:solidFill>
                 <a:latin typeface="Raleway" pitchFamily="34" charset="0"/>
                 <a:ea typeface="Raleway" pitchFamily="34" charset="-122"/>
@@ -4947,7 +5207,7 @@
             <a:r>
               <a:rPr lang="en-US" sz="1400" dirty="0">
                 <a:solidFill>
-                  <a:srgbClr val="B8C4EC"/>
+                  <a:srgbClr val="4A5578"/>
                 </a:solidFill>
               </a:rPr>
               <a:t>municípios atendidos</a:t>
@@ -4983,7 +5243,7 @@
             <a:r>
               <a:rPr lang="en-US" sz="4800" b="1" dirty="0">
                 <a:solidFill>
-                  <a:srgbClr val="FFFFFF"/>
+                  <a:srgbClr val="0D1150"/>
                 </a:solidFill>
                 <a:latin typeface="Raleway" pitchFamily="34" charset="0"/>
                 <a:ea typeface="Raleway" pitchFamily="34" charset="-122"/>
@@ -5022,7 +5282,7 @@
             <a:r>
               <a:rPr lang="en-US" sz="1400" dirty="0">
                 <a:solidFill>
-                  <a:srgbClr val="B8C4EC"/>
+                  <a:srgbClr val="4A5578"/>
                 </a:solidFill>
               </a:rPr>
               <a:t>início da atuação</a:t>
@@ -5058,7 +5318,7 @@
             <a:r>
               <a:rPr lang="en-US" sz="4800" b="1" dirty="0">
                 <a:solidFill>
-                  <a:srgbClr val="FFFFFF"/>
+                  <a:srgbClr val="0D1150"/>
                 </a:solidFill>
                 <a:latin typeface="Raleway" pitchFamily="34" charset="0"/>
                 <a:ea typeface="Raleway" pitchFamily="34" charset="-122"/>
@@ -5097,7 +5357,7 @@
             <a:r>
               <a:rPr lang="en-US" sz="1400" dirty="0">
                 <a:solidFill>
-                  <a:srgbClr val="B8C4EC"/>
+                  <a:srgbClr val="4A5578"/>
                 </a:solidFill>
               </a:rPr>
               <a:t>frentes de atuação</a:t>
@@ -5133,7 +5393,7 @@
             <a:r>
               <a:rPr lang="en-US" sz="1500" b="1" dirty="0">
                 <a:solidFill>
-                  <a:srgbClr val="FFFFFF"/>
+                  <a:srgbClr val="0D1150"/>
                 </a:solidFill>
               </a:rPr>
               <a:t>Parceiros institucionais</a:t>
@@ -5163,7 +5423,7 @@
           </a:solidFill>
           <a:ln w="12700">
             <a:solidFill>
-              <a:srgbClr val="FFFFFF"/>
+              <a:srgbClr val="D9E1F2"/>
             </a:solidFill>
             <a:prstDash val="solid"/>
           </a:ln>
@@ -5295,7 +5555,7 @@
             <a:lvl1pPr>
               <a:defRPr sz="1000">
                 <a:solidFill>
-                  <a:srgbClr val="B8C4EC"/>
+                  <a:srgbClr val="4A5578"/>
                 </a:solidFill>
                 <a:latin typeface="Montserrat"/>
                 <a:ea typeface="Montserrat"/>
@@ -5367,7 +5627,7 @@
             <a:r>
               <a:rPr lang="en-US" sz="1200" b="1" spc="400" kern="0" dirty="0">
                 <a:solidFill>
-                  <a:schemeClr val="accent1"/>
+                  <a:srgbClr val="004AAD"/>
                 </a:solidFill>
                 <a:latin typeface="Montserrat" pitchFamily="34" charset="0"/>
                 <a:ea typeface="Montserrat" pitchFamily="34" charset="-122"/>
@@ -5408,7 +5668,7 @@
             <a:r>
               <a:rPr lang="en-US" sz="3000" dirty="0">
                 <a:solidFill>
-                  <a:schemeClr val="bg1"/>
+                  <a:srgbClr val="0D1150"/>
                 </a:solidFill>
                 <a:latin typeface="Raleway" pitchFamily="34" charset="0"/>
                 <a:ea typeface="Raleway" pitchFamily="34" charset="-122"/>
@@ -5422,7 +5682,7 @@
             <a:r>
               <a:rPr lang="en-US" sz="3000" b="1" dirty="0">
                 <a:solidFill>
-                  <a:srgbClr val="00C2CB"/>
+                  <a:srgbClr val="004AAD"/>
                 </a:solidFill>
                 <a:latin typeface="Raleway" pitchFamily="34" charset="0"/>
                 <a:ea typeface="Raleway" pitchFamily="34" charset="-122"/>
@@ -5449,11 +5709,11 @@
             <a:avLst/>
           </a:prstGeom>
           <a:solidFill>
-            <a:srgbClr val="00C2CB"/>
+            <a:srgbClr val="004AAD"/>
           </a:solidFill>
           <a:ln w="12700">
             <a:solidFill>
-              <a:srgbClr val="00C2CB"/>
+              <a:srgbClr val="004AAD"/>
             </a:solidFill>
             <a:prstDash val="solid"/>
           </a:ln>
@@ -5486,7 +5746,7 @@
             <a:r>
               <a:rPr lang="en-US" sz="2600" b="1" dirty="0">
                 <a:solidFill>
-                  <a:srgbClr val="0D1150"/>
+                  <a:srgbClr val="FFFFFF"/>
                 </a:solidFill>
               </a:rPr>
               <a:t>+</a:t>
@@ -5522,7 +5782,7 @@
             <a:r>
               <a:rPr lang="en-US" sz="1500" b="1" dirty="0">
                 <a:solidFill>
-                  <a:srgbClr val="FFFFFF"/>
+                  <a:srgbClr val="0D1150"/>
                 </a:solidFill>
               </a:rPr>
               <a:t>RECURSOS</a:t>
@@ -5558,7 +5818,7 @@
             <a:r>
               <a:rPr lang="en-US" sz="1300" dirty="0">
                 <a:solidFill>
-                  <a:srgbClr val="B8C4EC"/>
+                  <a:srgbClr val="4A5578"/>
                 </a:solidFill>
               </a:rPr>
               <a:t>Captação e ampliação de recursos federais e estaduais, com habilitações, programas e propostas técnicas que aumentam o orçamento da saúde do município.</a:t>
@@ -5584,7 +5844,7 @@
           <a:noFill/>
           <a:ln w="9525">
             <a:solidFill>
-              <a:srgbClr val="2A3290"/>
+              <a:srgbClr val="E1E7F4"/>
             </a:solidFill>
             <a:prstDash val="solid"/>
           </a:ln>
@@ -5605,11 +5865,11 @@
             <a:avLst/>
           </a:prstGeom>
           <a:solidFill>
-            <a:srgbClr val="00C2CB"/>
+            <a:srgbClr val="004AAD"/>
           </a:solidFill>
           <a:ln w="12700">
             <a:solidFill>
-              <a:srgbClr val="00C2CB"/>
+              <a:srgbClr val="004AAD"/>
             </a:solidFill>
             <a:prstDash val="solid"/>
           </a:ln>
@@ -5642,7 +5902,7 @@
             <a:r>
               <a:rPr lang="en-US" sz="2600" b="1" dirty="0">
                 <a:solidFill>
-                  <a:srgbClr val="0D1150"/>
+                  <a:srgbClr val="FFFFFF"/>
                 </a:solidFill>
               </a:rPr>
               <a:t>+</a:t>
@@ -5678,7 +5938,7 @@
             <a:r>
               <a:rPr lang="en-US" sz="1500" b="1" dirty="0">
                 <a:solidFill>
-                  <a:srgbClr val="FFFFFF"/>
+                  <a:srgbClr val="0D1150"/>
                 </a:solidFill>
               </a:rPr>
               <a:t>SEGURANÇA FINANCEIRA</a:t>
@@ -5714,7 +5974,7 @@
             <a:r>
               <a:rPr lang="en-US" sz="1300" dirty="0">
                 <a:solidFill>
-                  <a:srgbClr val="B8C4EC"/>
+                  <a:srgbClr val="4A5578"/>
                 </a:solidFill>
               </a:rPr>
               <a:t>Aplicação e priorização dos recursos vinculados federais e estaduais, liberando o recurso próprio para as necessidades definidas pelo município.</a:t>
@@ -5740,7 +6000,7 @@
           <a:noFill/>
           <a:ln w="9525">
             <a:solidFill>
-              <a:srgbClr val="2A3290"/>
+              <a:srgbClr val="E1E7F4"/>
             </a:solidFill>
             <a:prstDash val="solid"/>
           </a:ln>
@@ -5761,11 +6021,11 @@
             <a:avLst/>
           </a:prstGeom>
           <a:solidFill>
-            <a:srgbClr val="00C2CB"/>
+            <a:srgbClr val="004AAD"/>
           </a:solidFill>
           <a:ln w="12700">
             <a:solidFill>
-              <a:srgbClr val="00C2CB"/>
+              <a:srgbClr val="004AAD"/>
             </a:solidFill>
             <a:prstDash val="solid"/>
           </a:ln>
@@ -5798,7 +6058,7 @@
             <a:r>
               <a:rPr lang="en-US" sz="2600" b="1" dirty="0">
                 <a:solidFill>
-                  <a:srgbClr val="0D1150"/>
+                  <a:srgbClr val="FFFFFF"/>
                 </a:solidFill>
               </a:rPr>
               <a:t>+</a:t>
@@ -5834,7 +6094,7 @@
             <a:r>
               <a:rPr lang="en-US" sz="1500" b="1" dirty="0">
                 <a:solidFill>
-                  <a:srgbClr val="FFFFFF"/>
+                  <a:srgbClr val="0D1150"/>
                 </a:solidFill>
               </a:rPr>
               <a:t>INFORMAÇÃO RÁPIDA E CONFIÁVEL</a:t>
@@ -5870,7 +6130,7 @@
             <a:r>
               <a:rPr lang="en-US" sz="1300" dirty="0">
                 <a:solidFill>
-                  <a:srgbClr val="B8C4EC"/>
+                  <a:srgbClr val="4A5578"/>
                 </a:solidFill>
               </a:rPr>
               <a:t>Acompanhamento diário de portarias e publicações do Ministério da Saúde e da Secretaria Estadual, com o impacto para o município, espaço para dúvidas e indicação de providências.</a:t>
@@ -5896,7 +6156,7 @@
           <a:noFill/>
           <a:ln w="9525">
             <a:solidFill>
-              <a:srgbClr val="2A3290"/>
+              <a:srgbClr val="E1E7F4"/>
             </a:solidFill>
             <a:prstDash val="solid"/>
           </a:ln>
@@ -5917,11 +6177,11 @@
             <a:avLst/>
           </a:prstGeom>
           <a:solidFill>
-            <a:srgbClr val="00C2CB"/>
+            <a:srgbClr val="004AAD"/>
           </a:solidFill>
           <a:ln w="12700">
             <a:solidFill>
-              <a:srgbClr val="00C2CB"/>
+              <a:srgbClr val="004AAD"/>
             </a:solidFill>
             <a:prstDash val="solid"/>
           </a:ln>
@@ -5954,7 +6214,7 @@
             <a:r>
               <a:rPr lang="en-US" sz="2600" b="1" dirty="0">
                 <a:solidFill>
-                  <a:srgbClr val="0D1150"/>
+                  <a:srgbClr val="FFFFFF"/>
                 </a:solidFill>
               </a:rPr>
               <a:t>+</a:t>
@@ -5990,7 +6250,7 @@
             <a:r>
               <a:rPr lang="en-US" sz="1500" b="1" dirty="0">
                 <a:solidFill>
-                  <a:srgbClr val="FFFFFF"/>
+                  <a:srgbClr val="0D1150"/>
                 </a:solidFill>
               </a:rPr>
               <a:t>CUMPRIMENTO NORMATIVO</a:t>
@@ -6026,7 +6286,7 @@
             <a:r>
               <a:rPr lang="en-US" sz="1300" dirty="0">
                 <a:solidFill>
-                  <a:srgbClr val="B8C4EC"/>
+                  <a:srgbClr val="4A5578"/>
                 </a:solidFill>
               </a:rPr>
               <a:t>Correto preenchimento dos sistemas da saúde e elaboração e atualização do Plano de Saúde, PAS, RDQA, RAG e demais instrumentos no DigiSUS.</a:t>
@@ -6052,7 +6312,7 @@
           <a:noFill/>
           <a:ln w="9525">
             <a:solidFill>
-              <a:srgbClr val="2A3290"/>
+              <a:srgbClr val="E1E7F4"/>
             </a:solidFill>
             <a:prstDash val="solid"/>
           </a:ln>
@@ -6073,11 +6333,11 @@
             <a:avLst/>
           </a:prstGeom>
           <a:solidFill>
-            <a:srgbClr val="00C2CB"/>
+            <a:srgbClr val="004AAD"/>
           </a:solidFill>
           <a:ln w="12700">
             <a:solidFill>
-              <a:srgbClr val="00C2CB"/>
+              <a:srgbClr val="004AAD"/>
             </a:solidFill>
             <a:prstDash val="solid"/>
           </a:ln>
@@ -6110,7 +6370,7 @@
             <a:r>
               <a:rPr lang="en-US" sz="2600" b="1" dirty="0">
                 <a:solidFill>
-                  <a:srgbClr val="0D1150"/>
+                  <a:srgbClr val="FFFFFF"/>
                 </a:solidFill>
               </a:rPr>
               <a:t>+</a:t>
@@ -6146,7 +6406,7 @@
             <a:r>
               <a:rPr lang="en-US" sz="1500" b="1" dirty="0">
                 <a:solidFill>
-                  <a:srgbClr val="FFFFFF"/>
+                  <a:srgbClr val="0D1150"/>
                 </a:solidFill>
               </a:rPr>
               <a:t>SEGURANÇA JURÍDICO-SANITÁRIA NA GESTÃO</a:t>
@@ -6182,7 +6442,7 @@
             <a:r>
               <a:rPr lang="en-US" sz="1300" dirty="0">
                 <a:solidFill>
-                  <a:srgbClr val="B8C4EC"/>
+                  <a:srgbClr val="4A5578"/>
                 </a:solidFill>
               </a:rPr>
               <a:t>Apoio técnico-normativo na instrução de processos licitatórios e contratações públicas, na organização de documentos e em subsídios técnicos para respostas a Tribunais de Contas, Ministério Público e demais órgãos de controle.</a:t>
@@ -6221,7 +6481,7 @@
             <a:lvl1pPr>
               <a:defRPr sz="1000">
                 <a:solidFill>
-                  <a:srgbClr val="B8C4EC"/>
+                  <a:srgbClr val="4A5578"/>
                 </a:solidFill>
                 <a:latin typeface="Montserrat"/>
                 <a:ea typeface="Montserrat"/>
@@ -6266,10 +6526,10 @@
       </p:grpSpPr>
       <p:sp>
         <p:nvSpPr>
-          <p:cNvPr id="2" name="Text 1"/>
+          <p:cNvPr id="2" name="Text 2"/>
           <p:cNvSpPr/>
           <p:nvPr>
-            <p:ph idx="102" type="body" hasCustomPrompt="1"/>
+            <p:ph idx="103" type="body" hasCustomPrompt="1"/>
           </p:nvPr>
         </p:nvSpPr>
         <p:spPr>
@@ -6293,7 +6553,7 @@
             <a:r>
               <a:rPr lang="en-US" sz="1200" b="1" spc="400" kern="0" dirty="0">
                 <a:solidFill>
-                  <a:schemeClr val="accent1"/>
+                  <a:srgbClr val="00C2CB"/>
                 </a:solidFill>
                 <a:latin typeface="Montserrat" pitchFamily="34" charset="0"/>
                 <a:ea typeface="Montserrat" pitchFamily="34" charset="-122"/>
@@ -6307,10 +6567,10 @@
       </p:sp>
       <p:sp>
         <p:nvSpPr>
-          <p:cNvPr id="3" name="Text 1"/>
+          <p:cNvPr id="3" name="Text 2"/>
           <p:cNvSpPr/>
           <p:nvPr>
-            <p:ph idx="103" type="title" hasCustomPrompt="1"/>
+            <p:ph idx="104" type="title" hasCustomPrompt="1"/>
           </p:nvPr>
         </p:nvSpPr>
         <p:spPr>
@@ -6334,7 +6594,7 @@
             <a:r>
               <a:rPr lang="en-US" sz="3000" dirty="0">
                 <a:solidFill>
-                  <a:schemeClr val="bg1"/>
+                  <a:srgbClr val="FFFFFF"/>
                 </a:solidFill>
                 <a:latin typeface="Raleway" pitchFamily="34" charset="0"/>
                 <a:ea typeface="Raleway" pitchFamily="34" charset="-122"/>
@@ -7631,7 +7891,7 @@
             <a:r>
               <a:rPr lang="en-US" sz="1200" b="1" spc="400" kern="0" dirty="0">
                 <a:solidFill>
-                  <a:schemeClr val="accent1"/>
+                  <a:srgbClr val="004AAD"/>
                 </a:solidFill>
                 <a:latin typeface="Montserrat" pitchFamily="34" charset="0"/>
                 <a:ea typeface="Montserrat" pitchFamily="34" charset="-122"/>
@@ -7672,7 +7932,7 @@
             <a:r>
               <a:rPr lang="en-US" sz="3000" dirty="0">
                 <a:solidFill>
-                  <a:schemeClr val="bg1"/>
+                  <a:srgbClr val="0D1150"/>
                 </a:solidFill>
                 <a:latin typeface="Raleway" pitchFamily="34" charset="0"/>
                 <a:ea typeface="Raleway" pitchFamily="34" charset="-122"/>
@@ -7686,7 +7946,7 @@
             <a:r>
               <a:rPr lang="en-US" sz="3000" b="1" dirty="0">
                 <a:solidFill>
-                  <a:srgbClr val="00C2CB"/>
+                  <a:srgbClr val="004AAD"/>
                 </a:solidFill>
                 <a:latin typeface="Raleway" pitchFamily="34" charset="0"/>
                 <a:ea typeface="Raleway" pitchFamily="34" charset="-122"/>
@@ -7715,11 +7975,11 @@
             </a:avLst>
           </a:prstGeom>
           <a:solidFill>
-            <a:srgbClr val="151A6B"/>
+            <a:srgbClr val="EEF2FB"/>
           </a:solidFill>
           <a:ln w="12700">
             <a:solidFill>
-              <a:srgbClr val="2A3290"/>
+              <a:srgbClr val="D9E1F2"/>
             </a:solidFill>
             <a:prstDash val="solid"/>
           </a:ln>
@@ -7740,11 +8000,11 @@
             <a:avLst/>
           </a:prstGeom>
           <a:solidFill>
-            <a:srgbClr val="00C2CB"/>
+            <a:srgbClr val="004AAD"/>
           </a:solidFill>
           <a:ln w="12700">
             <a:solidFill>
-              <a:srgbClr val="00C2CB"/>
+              <a:srgbClr val="004AAD"/>
             </a:solidFill>
             <a:prstDash val="solid"/>
           </a:ln>
@@ -7801,7 +8061,7 @@
             <a:r>
               <a:rPr lang="en-US" sz="1900" b="1" dirty="0">
                 <a:solidFill>
-                  <a:srgbClr val="FFFFFF"/>
+                  <a:srgbClr val="0D1150"/>
                 </a:solidFill>
               </a:rPr>
               <a:t>Diagnóstico situacional</a:t>
@@ -7837,7 +8097,7 @@
             <a:r>
               <a:rPr lang="en-US" sz="1400" dirty="0">
                 <a:solidFill>
-                  <a:srgbClr val="B8C4EC"/>
+                  <a:srgbClr val="4A5578"/>
                 </a:solidFill>
               </a:rPr>
               <a:t>Raio-x da gestão municipal da saúde, com prioridades e oportunidades identificadas.</a:t>
@@ -7871,9 +8131,9 @@
               <a:buNone/>
             </a:pPr>
             <a:r>
-              <a:rPr lang="en-US" sz="1300" i="1" dirty="0">
-                <a:solidFill>
-                  <a:srgbClr val="00C2CB"/>
+              <a:rPr lang="en-US" sz="1300" b="1" i="1" dirty="0">
+                <a:solidFill>
+                  <a:srgbClr val="004AAD"/>
                 </a:solidFill>
               </a:rPr>
               <a:t>Contratado de forma autônoma ou incluído na consultoria completa.</a:t>
@@ -7899,11 +8159,11 @@
             </a:avLst>
           </a:prstGeom>
           <a:solidFill>
-            <a:srgbClr val="151A6B"/>
+            <a:srgbClr val="EEF2FB"/>
           </a:solidFill>
           <a:ln w="12700">
             <a:solidFill>
-              <a:srgbClr val="2A3290"/>
+              <a:srgbClr val="D9E1F2"/>
             </a:solidFill>
             <a:prstDash val="solid"/>
           </a:ln>
@@ -7924,11 +8184,11 @@
             <a:avLst/>
           </a:prstGeom>
           <a:solidFill>
-            <a:srgbClr val="00C2CB"/>
+            <a:srgbClr val="004AAD"/>
           </a:solidFill>
           <a:ln w="12700">
             <a:solidFill>
-              <a:srgbClr val="00C2CB"/>
+              <a:srgbClr val="004AAD"/>
             </a:solidFill>
             <a:prstDash val="solid"/>
           </a:ln>
@@ -7985,7 +8245,7 @@
             <a:r>
               <a:rPr lang="en-US" sz="1900" b="1" dirty="0">
                 <a:solidFill>
-                  <a:srgbClr val="FFFFFF"/>
+                  <a:srgbClr val="0D1150"/>
                 </a:solidFill>
               </a:rPr>
               <a:t>Assessoria em frentes específicas</a:t>
@@ -8021,7 +8281,7 @@
             <a:r>
               <a:rPr lang="en-US" sz="1400" dirty="0">
                 <a:solidFill>
-                  <a:srgbClr val="B8C4EC"/>
+                  <a:srgbClr val="4A5578"/>
                 </a:solidFill>
               </a:rPr>
               <a:t>Atuação dirigida a uma necessidade pontual, como:</a:t>
@@ -8061,7 +8321,7 @@
             <a:r>
               <a:rPr lang="en-US" sz="1400" dirty="0">
                 <a:solidFill>
-                  <a:srgbClr val="FFFFFF"/>
+                  <a:srgbClr val="0D1150"/>
                 </a:solidFill>
               </a:rPr>
               <a:t>Revisão de teto MAC</a:t>
@@ -8079,7 +8339,7 @@
             <a:r>
               <a:rPr lang="en-US" sz="1400" dirty="0">
                 <a:solidFill>
-                  <a:srgbClr val="FFFFFF"/>
+                  <a:srgbClr val="0D1150"/>
                 </a:solidFill>
               </a:rPr>
               <a:t>Análise de faturamento</a:t>
@@ -8097,7 +8357,7 @@
             <a:r>
               <a:rPr lang="en-US" sz="1400" dirty="0">
                 <a:solidFill>
-                  <a:srgbClr val="FFFFFF"/>
+                  <a:srgbClr val="0D1150"/>
                 </a:solidFill>
               </a:rPr>
               <a:t>Estudo de captação</a:t>
@@ -8115,7 +8375,7 @@
             <a:r>
               <a:rPr lang="en-US" sz="1400" dirty="0">
                 <a:solidFill>
-                  <a:srgbClr val="FFFFFF"/>
+                  <a:srgbClr val="0D1150"/>
                 </a:solidFill>
               </a:rPr>
               <a:t>Contratualização</a:t>
@@ -8145,7 +8405,7 @@
           </a:solidFill>
           <a:ln w="12700">
             <a:solidFill>
-              <a:srgbClr val="00C2CB"/>
+              <a:srgbClr val="004AAD"/>
             </a:solidFill>
             <a:prstDash val="solid"/>
           </a:ln>
@@ -8166,11 +8426,11 @@
             <a:avLst/>
           </a:prstGeom>
           <a:solidFill>
-            <a:srgbClr val="00C2CB"/>
+            <a:srgbClr val="FFFFFF"/>
           </a:solidFill>
           <a:ln w="12700">
             <a:solidFill>
-              <a:srgbClr val="00C2CB"/>
+              <a:srgbClr val="FFFFFF"/>
             </a:solidFill>
             <a:prstDash val="solid"/>
           </a:ln>
@@ -8263,7 +8523,7 @@
             <a:r>
               <a:rPr lang="en-US" sz="1400" dirty="0">
                 <a:solidFill>
-                  <a:srgbClr val="FFFFFF"/>
+                  <a:srgbClr val="DCE6FA"/>
                 </a:solidFill>
               </a:rPr>
               <a:t>Diagnóstico e atuação contínua nas cinco frentes do Método Desenvolve.</a:t>
@@ -8297,7 +8557,7 @@
               <a:buNone/>
             </a:pPr>
             <a:r>
-              <a:rPr lang="en-US" sz="1300" i="1" dirty="0">
+              <a:rPr lang="en-US" sz="1300" b="1" i="1" dirty="0">
                 <a:solidFill>
                   <a:srgbClr val="00C2CB"/>
                 </a:solidFill>
@@ -8338,7 +8598,7 @@
             <a:lvl1pPr>
               <a:defRPr sz="1000">
                 <a:solidFill>
-                  <a:srgbClr val="B8C4EC"/>
+                  <a:srgbClr val="4A5578"/>
                 </a:solidFill>
                 <a:latin typeface="Montserrat"/>
                 <a:ea typeface="Montserrat"/>
@@ -8383,9 +8643,11 @@
       </p:grpSpPr>
       <p:sp>
         <p:nvSpPr>
-          <p:cNvPr id="2" name="Text 0"/>
-          <p:cNvSpPr txBox="1"/>
-          <p:nvPr/>
+          <p:cNvPr id="2" name="Text 1"/>
+          <p:cNvSpPr/>
+          <p:nvPr>
+            <p:ph idx="102" type="body" hasCustomPrompt="1"/>
+          </p:nvPr>
         </p:nvSpPr>
         <p:spPr>
           <a:xfrm>
@@ -8399,7 +8661,7 @@
           <a:ln/>
         </p:spPr>
         <p:txBody>
-          <a:bodyPr wrap="square" lIns="0" tIns="0" rIns="0" bIns="0" rtlCol="0" anchor="ctr"/>
+          <a:bodyPr wrap="square" lIns="0" tIns="0" rIns="0" bIns="0" rtlCol="0"/>
           <a:lstStyle/>
           <a:p>
             <a:pPr indent="0" marL="0">
@@ -8408,8 +8670,11 @@
             <a:r>
               <a:rPr lang="en-US" sz="1200" b="1" spc="400" kern="0" dirty="0">
                 <a:solidFill>
-                  <a:srgbClr val="00C2CB"/>
-                </a:solidFill>
+                  <a:srgbClr val="004AAD"/>
+                </a:solidFill>
+                <a:latin typeface="Montserrat" pitchFamily="34" charset="0"/>
+                <a:ea typeface="Montserrat" pitchFamily="34" charset="-122"/>
+                <a:cs typeface="Montserrat" pitchFamily="34" charset="-120"/>
               </a:rPr>
               <a:t>EQUIPE E PRÓXIMOS PASSOS</a:t>
             </a:r>
@@ -8420,13 +8685,15 @@
       <p:sp>
         <p:nvSpPr>
           <p:cNvPr id="3" name="Text 1"/>
-          <p:cNvSpPr txBox="1"/>
-          <p:nvPr/>
+          <p:cNvSpPr/>
+          <p:nvPr>
+            <p:ph idx="103" type="title" hasCustomPrompt="1"/>
+          </p:nvPr>
         </p:nvSpPr>
         <p:spPr>
           <a:xfrm>
             <a:off x="548640" y="731520"/>
-            <a:ext cx="11064240" cy="640080"/>
+            <a:ext cx="11064240" cy="1005840"/>
           </a:xfrm>
           <a:prstGeom prst="rect">
             <a:avLst/>
@@ -8444,7 +8711,7 @@
             <a:r>
               <a:rPr lang="en-US" sz="3000" dirty="0">
                 <a:solidFill>
-                  <a:srgbClr val="FFFFFF"/>
+                  <a:srgbClr val="0D1150"/>
                 </a:solidFill>
                 <a:latin typeface="Raleway" pitchFamily="34" charset="0"/>
                 <a:ea typeface="Raleway" pitchFamily="34" charset="-122"/>
@@ -8458,7 +8725,7 @@
             <a:r>
               <a:rPr lang="en-US" sz="3000" b="1" dirty="0">
                 <a:solidFill>
-                  <a:srgbClr val="00C2CB"/>
+                  <a:srgbClr val="004AAD"/>
                 </a:solidFill>
                 <a:latin typeface="Raleway" pitchFamily="34" charset="0"/>
                 <a:ea typeface="Raleway" pitchFamily="34" charset="-122"/>
@@ -8478,7 +8745,7 @@
         </p:nvSpPr>
         <p:spPr>
           <a:xfrm>
-            <a:off x="548640" y="1920240"/>
+            <a:off x="548640" y="1965960"/>
             <a:ext cx="3520440" cy="1188720"/>
           </a:xfrm>
           <a:prstGeom prst="roundRect">
@@ -8487,13 +8754,11 @@
             </a:avLst>
           </a:prstGeom>
           <a:solidFill>
-            <a:srgbClr val="0D1150">
-              <a:alpha val="85000"/>
-            </a:srgbClr>
+            <a:srgbClr val="EEF2FB"/>
           </a:solidFill>
           <a:ln w="12700">
             <a:solidFill>
-              <a:srgbClr val="3A4AA8"/>
+              <a:srgbClr val="D9E1F2"/>
             </a:solidFill>
             <a:prstDash val="solid"/>
           </a:ln>
@@ -8507,18 +8772,18 @@
         </p:nvSpPr>
         <p:spPr>
           <a:xfrm>
-            <a:off x="822960" y="2176272"/>
+            <a:off x="822960" y="2221992"/>
             <a:ext cx="676656" cy="676656"/>
           </a:xfrm>
           <a:prstGeom prst="ellipse">
             <a:avLst/>
           </a:prstGeom>
           <a:solidFill>
-            <a:srgbClr val="00C2CB"/>
+            <a:srgbClr val="004AAD"/>
           </a:solidFill>
           <a:ln w="12700">
             <a:solidFill>
-              <a:srgbClr val="00C2CB"/>
+              <a:srgbClr val="004AAD"/>
             </a:solidFill>
             <a:prstDash val="solid"/>
           </a:ln>
@@ -8532,7 +8797,7 @@
         </p:nvSpPr>
         <p:spPr>
           <a:xfrm>
-            <a:off x="822960" y="2176272"/>
+            <a:off x="822960" y="2221992"/>
             <a:ext cx="676656" cy="676656"/>
           </a:xfrm>
           <a:prstGeom prst="rect">
@@ -8551,7 +8816,7 @@
             <a:r>
               <a:rPr lang="en-US" sz="1600" b="1" dirty="0">
                 <a:solidFill>
-                  <a:srgbClr val="0D1150"/>
+                  <a:srgbClr val="FFFFFF"/>
                 </a:solidFill>
               </a:rPr>
               <a:t>DM</a:t>
@@ -8568,7 +8833,7 @@
         </p:nvSpPr>
         <p:spPr>
           <a:xfrm>
-            <a:off x="1664208" y="2103120"/>
+            <a:off x="1664208" y="2148840"/>
             <a:ext cx="2240280" cy="384048"/>
           </a:xfrm>
           <a:prstGeom prst="rect">
@@ -8587,7 +8852,7 @@
             <a:r>
               <a:rPr lang="en-US" sz="1600" b="1" dirty="0">
                 <a:solidFill>
-                  <a:srgbClr val="FFFFFF"/>
+                  <a:srgbClr val="0D1150"/>
                 </a:solidFill>
               </a:rPr>
               <a:t>Dr. Diego Meloni</a:t>
@@ -8604,7 +8869,7 @@
         </p:nvSpPr>
         <p:spPr>
           <a:xfrm>
-            <a:off x="1664208" y="2514600"/>
+            <a:off x="1664208" y="2560320"/>
             <a:ext cx="2240280" cy="457200"/>
           </a:xfrm>
           <a:prstGeom prst="rect">
@@ -8623,7 +8888,7 @@
             <a:r>
               <a:rPr lang="en-US" sz="1300" dirty="0">
                 <a:solidFill>
-                  <a:srgbClr val="B8C4EC"/>
+                  <a:srgbClr val="4A5578"/>
                 </a:solidFill>
               </a:rPr>
               <a:t>Diretor Técnico</a:t>
@@ -8640,7 +8905,7 @@
         </p:nvSpPr>
         <p:spPr>
           <a:xfrm>
-            <a:off x="4315968" y="1920240"/>
+            <a:off x="4315968" y="1965960"/>
             <a:ext cx="3520440" cy="1188720"/>
           </a:xfrm>
           <a:prstGeom prst="roundRect">
@@ -8649,13 +8914,11 @@
             </a:avLst>
           </a:prstGeom>
           <a:solidFill>
-            <a:srgbClr val="0D1150">
-              <a:alpha val="85000"/>
-            </a:srgbClr>
+            <a:srgbClr val="EEF2FB"/>
           </a:solidFill>
           <a:ln w="12700">
             <a:solidFill>
-              <a:srgbClr val="3A4AA8"/>
+              <a:srgbClr val="D9E1F2"/>
             </a:solidFill>
             <a:prstDash val="solid"/>
           </a:ln>
@@ -8669,18 +8932,18 @@
         </p:nvSpPr>
         <p:spPr>
           <a:xfrm>
-            <a:off x="4590288" y="2176272"/>
+            <a:off x="4590288" y="2221992"/>
             <a:ext cx="676656" cy="676656"/>
           </a:xfrm>
           <a:prstGeom prst="ellipse">
             <a:avLst/>
           </a:prstGeom>
           <a:solidFill>
-            <a:srgbClr val="00C2CB"/>
+            <a:srgbClr val="004AAD"/>
           </a:solidFill>
           <a:ln w="12700">
             <a:solidFill>
-              <a:srgbClr val="00C2CB"/>
+              <a:srgbClr val="004AAD"/>
             </a:solidFill>
             <a:prstDash val="solid"/>
           </a:ln>
@@ -8694,7 +8957,7 @@
         </p:nvSpPr>
         <p:spPr>
           <a:xfrm>
-            <a:off x="4590288" y="2176272"/>
+            <a:off x="4590288" y="2221992"/>
             <a:ext cx="676656" cy="676656"/>
           </a:xfrm>
           <a:prstGeom prst="rect">
@@ -8713,7 +8976,7 @@
             <a:r>
               <a:rPr lang="en-US" sz="1600" b="1" dirty="0">
                 <a:solidFill>
-                  <a:srgbClr val="0D1150"/>
+                  <a:srgbClr val="FFFFFF"/>
                 </a:solidFill>
               </a:rPr>
               <a:t>LN</a:t>
@@ -8730,7 +8993,7 @@
         </p:nvSpPr>
         <p:spPr>
           <a:xfrm>
-            <a:off x="5431536" y="2103120"/>
+            <a:off x="5431536" y="2148840"/>
             <a:ext cx="2240280" cy="384048"/>
           </a:xfrm>
           <a:prstGeom prst="rect">
@@ -8749,7 +9012,7 @@
             <a:r>
               <a:rPr lang="en-US" sz="1600" b="1" dirty="0">
                 <a:solidFill>
-                  <a:srgbClr val="FFFFFF"/>
+                  <a:srgbClr val="0D1150"/>
                 </a:solidFill>
               </a:rPr>
               <a:t>Luciana Nazar</a:t>
@@ -8766,7 +9029,7 @@
         </p:nvSpPr>
         <p:spPr>
           <a:xfrm>
-            <a:off x="5431536" y="2514600"/>
+            <a:off x="5431536" y="2560320"/>
             <a:ext cx="2240280" cy="457200"/>
           </a:xfrm>
           <a:prstGeom prst="rect">
@@ -8785,7 +9048,7 @@
             <a:r>
               <a:rPr lang="en-US" sz="1300" dirty="0">
                 <a:solidFill>
-                  <a:srgbClr val="B8C4EC"/>
+                  <a:srgbClr val="4A5578"/>
                 </a:solidFill>
               </a:rPr>
               <a:t>Diretora de Operação</a:t>
@@ -8802,7 +9065,7 @@
         </p:nvSpPr>
         <p:spPr>
           <a:xfrm>
-            <a:off x="8083296" y="1920240"/>
+            <a:off x="8083296" y="1965960"/>
             <a:ext cx="3520440" cy="1188720"/>
           </a:xfrm>
           <a:prstGeom prst="roundRect">
@@ -8811,13 +9074,11 @@
             </a:avLst>
           </a:prstGeom>
           <a:solidFill>
-            <a:srgbClr val="0D1150">
-              <a:alpha val="85000"/>
-            </a:srgbClr>
+            <a:srgbClr val="EEF2FB"/>
           </a:solidFill>
           <a:ln w="12700">
             <a:solidFill>
-              <a:srgbClr val="3A4AA8"/>
+              <a:srgbClr val="D9E1F2"/>
             </a:solidFill>
             <a:prstDash val="solid"/>
           </a:ln>
@@ -8831,18 +9092,18 @@
         </p:nvSpPr>
         <p:spPr>
           <a:xfrm>
-            <a:off x="8357616" y="2176272"/>
+            <a:off x="8357616" y="2221992"/>
             <a:ext cx="676656" cy="676656"/>
           </a:xfrm>
           <a:prstGeom prst="ellipse">
             <a:avLst/>
           </a:prstGeom>
           <a:solidFill>
-            <a:srgbClr val="00C2CB"/>
+            <a:srgbClr val="004AAD"/>
           </a:solidFill>
           <a:ln w="12700">
             <a:solidFill>
-              <a:srgbClr val="00C2CB"/>
+              <a:srgbClr val="004AAD"/>
             </a:solidFill>
             <a:prstDash val="solid"/>
           </a:ln>
@@ -8856,7 +9117,7 @@
         </p:nvSpPr>
         <p:spPr>
           <a:xfrm>
-            <a:off x="8357616" y="2176272"/>
+            <a:off x="8357616" y="2221992"/>
             <a:ext cx="676656" cy="676656"/>
           </a:xfrm>
           <a:prstGeom prst="rect">
@@ -8875,7 +9136,7 @@
             <a:r>
               <a:rPr lang="en-US" sz="1600" b="1" dirty="0">
                 <a:solidFill>
-                  <a:srgbClr val="0D1150"/>
+                  <a:srgbClr val="FFFFFF"/>
                 </a:solidFill>
               </a:rPr>
               <a:t>MS</a:t>
@@ -8892,7 +9153,7 @@
         </p:nvSpPr>
         <p:spPr>
           <a:xfrm>
-            <a:off x="9198864" y="2103120"/>
+            <a:off x="9198864" y="2148840"/>
             <a:ext cx="2240280" cy="384048"/>
           </a:xfrm>
           <a:prstGeom prst="rect">
@@ -8911,7 +9172,7 @@
             <a:r>
               <a:rPr lang="en-US" sz="1600" b="1" dirty="0">
                 <a:solidFill>
-                  <a:srgbClr val="FFFFFF"/>
+                  <a:srgbClr val="0D1150"/>
                 </a:solidFill>
               </a:rPr>
               <a:t>Dr. Murilo Santos</a:t>
@@ -8928,7 +9189,7 @@
         </p:nvSpPr>
         <p:spPr>
           <a:xfrm>
-            <a:off x="9198864" y="2514600"/>
+            <a:off x="9198864" y="2560320"/>
             <a:ext cx="2240280" cy="457200"/>
           </a:xfrm>
           <a:prstGeom prst="rect">
@@ -8947,7 +9208,7 @@
             <a:r>
               <a:rPr lang="en-US" sz="1300" dirty="0">
                 <a:solidFill>
-                  <a:srgbClr val="B8C4EC"/>
+                  <a:srgbClr val="4A5578"/>
                 </a:solidFill>
               </a:rPr>
               <a:t>Diretor Jurídico</a:t>
@@ -8961,7 +9222,7 @@
             <a:r>
               <a:rPr lang="en-US" sz="1300" dirty="0">
                 <a:solidFill>
-                  <a:srgbClr val="B8C4EC"/>
+                  <a:srgbClr val="4A5578"/>
                 </a:solidFill>
               </a:rPr>
               <a:t>OAB/SP 311.759</a:t>
@@ -8972,13 +9233,40 @@
       </p:sp>
       <p:sp>
         <p:nvSpPr>
-          <p:cNvPr id="19" name="Shape 17"/>
+          <p:cNvPr id="19" name="Próximos passos"/>
           <p:cNvSpPr/>
           <p:nvPr/>
         </p:nvSpPr>
         <p:spPr>
           <a:xfrm>
-            <a:off x="548640" y="3657600"/>
+            <a:off x="548640" y="3429000"/>
+            <a:ext cx="11091672" cy="1051560"/>
+          </a:xfrm>
+          <a:prstGeom prst="roundRect">
+            <a:avLst>
+              <a:gd name="adj" fmla="val 10435"/>
+            </a:avLst>
+          </a:prstGeom>
+          <a:solidFill>
+            <a:srgbClr val="004AAD"/>
+          </a:solidFill>
+          <a:ln w="12700">
+            <a:solidFill>
+              <a:srgbClr val="004AAD"/>
+            </a:solidFill>
+            <a:prstDash val="solid"/>
+          </a:ln>
+        </p:spPr>
+      </p:sp>
+      <p:sp>
+        <p:nvSpPr>
+          <p:cNvPr id="20" name="Shape 18"/>
+          <p:cNvSpPr/>
+          <p:nvPr/>
+        </p:nvSpPr>
+        <p:spPr>
+          <a:xfrm>
+            <a:off x="868680" y="3671316"/>
             <a:ext cx="566928" cy="566928"/>
           </a:xfrm>
           <a:prstGeom prst="ellipse">
@@ -8997,50 +9285,50 @@
       </p:sp>
       <p:sp>
         <p:nvSpPr>
-          <p:cNvPr id="20" name="Text 18"/>
-          <p:cNvSpPr txBox="1"/>
-          <p:nvPr/>
-        </p:nvSpPr>
-        <p:spPr>
-          <a:xfrm>
-            <a:off x="548640" y="3657600"/>
-            <a:ext cx="566928" cy="566928"/>
-          </a:xfrm>
-          <a:prstGeom prst="rect">
-            <a:avLst/>
-          </a:prstGeom>
-          <a:noFill/>
-          <a:ln/>
-        </p:spPr>
-        <p:txBody>
-          <a:bodyPr wrap="square" lIns="0" tIns="0" rIns="0" bIns="0" rtlCol="0" anchor="ctr"/>
-          <a:lstStyle/>
-          <a:p>
-            <a:pPr algn="ctr" indent="0" marL="0">
-              <a:buNone/>
-            </a:pPr>
-            <a:r>
-              <a:rPr lang="en-US" sz="1800" b="1" dirty="0">
-                <a:solidFill>
-                  <a:srgbClr val="004AAD"/>
-                </a:solidFill>
-              </a:rPr>
-              <a:t>1</a:t>
-            </a:r>
-            <a:endParaRPr lang="en-US" sz="1800" dirty="0"/>
-          </a:p>
-        </p:txBody>
-      </p:sp>
-      <p:sp>
-        <p:nvSpPr>
           <p:cNvPr id="21" name="Text 19"/>
           <p:cNvSpPr txBox="1"/>
           <p:nvPr/>
         </p:nvSpPr>
         <p:spPr>
           <a:xfrm>
-            <a:off x="1280160" y="3657600"/>
-            <a:ext cx="2377440" cy="566928"/>
+            <a:off x="868680" y="3671316"/>
+            <a:ext cx="566928" cy="566928"/>
+          </a:xfrm>
+          <a:prstGeom prst="rect">
+            <a:avLst/>
+          </a:prstGeom>
+          <a:noFill/>
+          <a:ln/>
+        </p:spPr>
+        <p:txBody>
+          <a:bodyPr wrap="square" lIns="0" tIns="0" rIns="0" bIns="0" rtlCol="0" anchor="ctr"/>
+          <a:lstStyle/>
+          <a:p>
+            <a:pPr algn="ctr" indent="0" marL="0">
+              <a:buNone/>
+            </a:pPr>
+            <a:r>
+              <a:rPr lang="en-US" sz="1800" b="1" dirty="0">
+                <a:solidFill>
+                  <a:srgbClr val="004AAD"/>
+                </a:solidFill>
+              </a:rPr>
+              <a:t>1</a:t>
+            </a:r>
+            <a:endParaRPr lang="en-US" sz="1800" dirty="0"/>
+          </a:p>
+        </p:txBody>
+      </p:sp>
+      <p:sp>
+        <p:nvSpPr>
+          <p:cNvPr id="22" name="Text 20"/>
+          <p:cNvSpPr txBox="1"/>
+          <p:nvPr/>
+        </p:nvSpPr>
+        <p:spPr>
+          <a:xfrm>
+            <a:off x="1600200" y="3671316"/>
+            <a:ext cx="2331720" cy="566928"/>
           </a:xfrm>
           <a:prstGeom prst="rect">
             <a:avLst/>
@@ -9069,7 +9357,7 @@
       </p:sp>
       <p:pic>
         <p:nvPicPr>
-          <p:cNvPr id="22" name="Image 0" descr="preencoded.png">    </p:cNvPr>
+          <p:cNvPr id="23" name="Image 0" descr="preencoded.png">    </p:cNvPr>
           <p:cNvPicPr>
             <a:picLocks noChangeAspect="1"/>
           </p:cNvPicPr>
@@ -9083,7 +9371,7 @@
         </p:blipFill>
         <p:spPr>
           <a:xfrm>
-            <a:off x="3886200" y="3776472"/>
+            <a:off x="3977640" y="3790188"/>
             <a:ext cx="329184" cy="329184"/>
           </a:xfrm>
           <a:prstGeom prst="rect">
@@ -9093,13 +9381,13 @@
       </p:pic>
       <p:sp>
         <p:nvSpPr>
-          <p:cNvPr id="23" name="Shape 20"/>
+          <p:cNvPr id="24" name="Shape 21"/>
           <p:cNvSpPr/>
           <p:nvPr/>
         </p:nvSpPr>
         <p:spPr>
           <a:xfrm>
-            <a:off x="4315968" y="3657600"/>
+            <a:off x="4636008" y="3671316"/>
             <a:ext cx="566928" cy="566928"/>
           </a:xfrm>
           <a:prstGeom prst="ellipse">
@@ -9118,50 +9406,50 @@
       </p:sp>
       <p:sp>
         <p:nvSpPr>
-          <p:cNvPr id="24" name="Text 21"/>
-          <p:cNvSpPr txBox="1"/>
-          <p:nvPr/>
-        </p:nvSpPr>
-        <p:spPr>
-          <a:xfrm>
-            <a:off x="4315968" y="3657600"/>
-            <a:ext cx="566928" cy="566928"/>
-          </a:xfrm>
-          <a:prstGeom prst="rect">
-            <a:avLst/>
-          </a:prstGeom>
-          <a:noFill/>
-          <a:ln/>
-        </p:spPr>
-        <p:txBody>
-          <a:bodyPr wrap="square" lIns="0" tIns="0" rIns="0" bIns="0" rtlCol="0" anchor="ctr"/>
-          <a:lstStyle/>
-          <a:p>
-            <a:pPr algn="ctr" indent="0" marL="0">
-              <a:buNone/>
-            </a:pPr>
-            <a:r>
-              <a:rPr lang="en-US" sz="1800" b="1" dirty="0">
-                <a:solidFill>
-                  <a:srgbClr val="004AAD"/>
-                </a:solidFill>
-              </a:rPr>
-              <a:t>2</a:t>
-            </a:r>
-            <a:endParaRPr lang="en-US" sz="1800" dirty="0"/>
-          </a:p>
-        </p:txBody>
-      </p:sp>
-      <p:sp>
-        <p:nvSpPr>
           <p:cNvPr id="25" name="Text 22"/>
           <p:cNvSpPr txBox="1"/>
           <p:nvPr/>
         </p:nvSpPr>
         <p:spPr>
           <a:xfrm>
-            <a:off x="5047488" y="3657600"/>
-            <a:ext cx="2377440" cy="566928"/>
+            <a:off x="4636008" y="3671316"/>
+            <a:ext cx="566928" cy="566928"/>
+          </a:xfrm>
+          <a:prstGeom prst="rect">
+            <a:avLst/>
+          </a:prstGeom>
+          <a:noFill/>
+          <a:ln/>
+        </p:spPr>
+        <p:txBody>
+          <a:bodyPr wrap="square" lIns="0" tIns="0" rIns="0" bIns="0" rtlCol="0" anchor="ctr"/>
+          <a:lstStyle/>
+          <a:p>
+            <a:pPr algn="ctr" indent="0" marL="0">
+              <a:buNone/>
+            </a:pPr>
+            <a:r>
+              <a:rPr lang="en-US" sz="1800" b="1" dirty="0">
+                <a:solidFill>
+                  <a:srgbClr val="004AAD"/>
+                </a:solidFill>
+              </a:rPr>
+              <a:t>2</a:t>
+            </a:r>
+            <a:endParaRPr lang="en-US" sz="1800" dirty="0"/>
+          </a:p>
+        </p:txBody>
+      </p:sp>
+      <p:sp>
+        <p:nvSpPr>
+          <p:cNvPr id="26" name="Text 23"/>
+          <p:cNvSpPr txBox="1"/>
+          <p:nvPr/>
+        </p:nvSpPr>
+        <p:spPr>
+          <a:xfrm>
+            <a:off x="5367528" y="3671316"/>
+            <a:ext cx="2331720" cy="566928"/>
           </a:xfrm>
           <a:prstGeom prst="rect">
             <a:avLst/>
@@ -9190,7 +9478,7 @@
       </p:sp>
       <p:pic>
         <p:nvPicPr>
-          <p:cNvPr id="26" name="Image 1" descr="preencoded.png">    </p:cNvPr>
+          <p:cNvPr id="27" name="Image 1" descr="preencoded.png">    </p:cNvPr>
           <p:cNvPicPr>
             <a:picLocks noChangeAspect="1"/>
           </p:cNvPicPr>
@@ -9204,7 +9492,7 @@
         </p:blipFill>
         <p:spPr>
           <a:xfrm>
-            <a:off x="7653528" y="3776472"/>
+            <a:off x="7744968" y="3790188"/>
             <a:ext cx="329184" cy="329184"/>
           </a:xfrm>
           <a:prstGeom prst="rect">
@@ -9214,13 +9502,13 @@
       </p:pic>
       <p:sp>
         <p:nvSpPr>
-          <p:cNvPr id="27" name="Shape 23"/>
+          <p:cNvPr id="28" name="Shape 24"/>
           <p:cNvSpPr/>
           <p:nvPr/>
         </p:nvSpPr>
         <p:spPr>
           <a:xfrm>
-            <a:off x="8083296" y="3657600"/>
+            <a:off x="8403336" y="3671316"/>
             <a:ext cx="566928" cy="566928"/>
           </a:xfrm>
           <a:prstGeom prst="ellipse">
@@ -9239,50 +9527,14 @@
       </p:sp>
       <p:sp>
         <p:nvSpPr>
-          <p:cNvPr id="28" name="Text 24"/>
-          <p:cNvSpPr txBox="1"/>
-          <p:nvPr/>
-        </p:nvSpPr>
-        <p:spPr>
-          <a:xfrm>
-            <a:off x="8083296" y="3657600"/>
-            <a:ext cx="566928" cy="566928"/>
-          </a:xfrm>
-          <a:prstGeom prst="rect">
-            <a:avLst/>
-          </a:prstGeom>
-          <a:noFill/>
-          <a:ln/>
-        </p:spPr>
-        <p:txBody>
-          <a:bodyPr wrap="square" lIns="0" tIns="0" rIns="0" bIns="0" rtlCol="0" anchor="ctr"/>
-          <a:lstStyle/>
-          <a:p>
-            <a:pPr algn="ctr" indent="0" marL="0">
-              <a:buNone/>
-            </a:pPr>
-            <a:r>
-              <a:rPr lang="en-US" sz="1800" b="1" dirty="0">
-                <a:solidFill>
-                  <a:srgbClr val="004AAD"/>
-                </a:solidFill>
-              </a:rPr>
-              <a:t>3</a:t>
-            </a:r>
-            <a:endParaRPr lang="en-US" sz="1800" dirty="0"/>
-          </a:p>
-        </p:txBody>
-      </p:sp>
-      <p:sp>
-        <p:nvSpPr>
           <p:cNvPr id="29" name="Text 25"/>
           <p:cNvSpPr txBox="1"/>
           <p:nvPr/>
         </p:nvSpPr>
         <p:spPr>
           <a:xfrm>
-            <a:off x="8814816" y="3657600"/>
-            <a:ext cx="2377440" cy="566928"/>
+            <a:off x="8403336" y="3671316"/>
+            <a:ext cx="566928" cy="566928"/>
           </a:xfrm>
           <a:prstGeom prst="rect">
             <a:avLst/>
@@ -9294,6 +9546,42 @@
           <a:bodyPr wrap="square" lIns="0" tIns="0" rIns="0" bIns="0" rtlCol="0" anchor="ctr"/>
           <a:lstStyle/>
           <a:p>
+            <a:pPr algn="ctr" indent="0" marL="0">
+              <a:buNone/>
+            </a:pPr>
+            <a:r>
+              <a:rPr lang="en-US" sz="1800" b="1" dirty="0">
+                <a:solidFill>
+                  <a:srgbClr val="004AAD"/>
+                </a:solidFill>
+              </a:rPr>
+              <a:t>3</a:t>
+            </a:r>
+            <a:endParaRPr lang="en-US" sz="1800" dirty="0"/>
+          </a:p>
+        </p:txBody>
+      </p:sp>
+      <p:sp>
+        <p:nvSpPr>
+          <p:cNvPr id="30" name="Text 26"/>
+          <p:cNvSpPr txBox="1"/>
+          <p:nvPr/>
+        </p:nvSpPr>
+        <p:spPr>
+          <a:xfrm>
+            <a:off x="9134856" y="3671316"/>
+            <a:ext cx="2331720" cy="566928"/>
+          </a:xfrm>
+          <a:prstGeom prst="rect">
+            <a:avLst/>
+          </a:prstGeom>
+          <a:noFill/>
+          <a:ln/>
+        </p:spPr>
+        <p:txBody>
+          <a:bodyPr wrap="square" lIns="0" tIns="0" rIns="0" bIns="0" rtlCol="0" anchor="ctr"/>
+          <a:lstStyle/>
+          <a:p>
             <a:pPr indent="0" marL="0">
               <a:buNone/>
             </a:pPr>
@@ -9309,40 +9597,16 @@
           </a:p>
         </p:txBody>
       </p:sp>
-      <p:pic>
-        <p:nvPicPr>
-          <p:cNvPr id="30" name="Image 2" descr="/tmp/claude-0/-home-user/25c0be0f-0a5e-54d0-b86c-4757d56f039f/scratchpad/deck/assets/dsve-branco.png">    </p:cNvPr>
-          <p:cNvPicPr>
-            <a:picLocks noChangeAspect="1"/>
-          </p:cNvPicPr>
-          <p:nvPr/>
-        </p:nvPicPr>
-        <p:blipFill>
-          <a:blip r:embed="rId3"/>
-          <a:stretch>
-            <a:fillRect/>
-          </a:stretch>
-        </p:blipFill>
-        <p:spPr>
-          <a:xfrm>
-            <a:off x="548640" y="4892040"/>
-            <a:ext cx="2011680" cy="731520"/>
-          </a:xfrm>
-          <a:prstGeom prst="rect">
-            <a:avLst/>
-          </a:prstGeom>
-        </p:spPr>
-      </p:pic>
-      <p:sp>
-        <p:nvSpPr>
-          <p:cNvPr id="31" name="Text 26"/>
+      <p:sp>
+        <p:nvSpPr>
+          <p:cNvPr id="31" name="Text 27"/>
           <p:cNvSpPr txBox="1"/>
           <p:nvPr/>
         </p:nvSpPr>
         <p:spPr>
           <a:xfrm>
-            <a:off x="3108960" y="4956048"/>
-            <a:ext cx="2514600" cy="256032"/>
+            <a:off x="548640" y="4910328"/>
+            <a:ext cx="2926080" cy="256032"/>
           </a:xfrm>
           <a:prstGeom prst="rect">
             <a:avLst/>
@@ -9360,7 +9624,7 @@
             <a:r>
               <a:rPr lang="en-US" sz="1000" b="1" spc="300" kern="0" dirty="0">
                 <a:solidFill>
-                  <a:srgbClr val="00C2CB"/>
+                  <a:srgbClr val="004AAD"/>
                 </a:solidFill>
               </a:rPr>
               <a:t>SITE</a:t>
@@ -9371,14 +9635,14 @@
       </p:sp>
       <p:sp>
         <p:nvSpPr>
-          <p:cNvPr id="32" name="Text 27"/>
+          <p:cNvPr id="32" name="Text 28"/>
           <p:cNvSpPr txBox="1"/>
           <p:nvPr/>
         </p:nvSpPr>
         <p:spPr>
           <a:xfrm>
-            <a:off x="3108960" y="5230368"/>
-            <a:ext cx="2514600" cy="365760"/>
+            <a:off x="548640" y="5184648"/>
+            <a:ext cx="2926080" cy="365760"/>
           </a:xfrm>
           <a:prstGeom prst="rect">
             <a:avLst/>
@@ -9396,7 +9660,7 @@
             <a:r>
               <a:rPr lang="en-US" sz="1500" dirty="0">
                 <a:solidFill>
-                  <a:srgbClr val="FFFFFF"/>
+                  <a:srgbClr val="0D1150"/>
                 </a:solidFill>
               </a:rPr>
               <a:t>grupodesenvolve.com.br</a:t>
@@ -9407,14 +9671,14 @@
       </p:sp>
       <p:sp>
         <p:nvSpPr>
-          <p:cNvPr id="33" name="Text 28"/>
+          <p:cNvPr id="33" name="Text 29"/>
           <p:cNvSpPr txBox="1"/>
           <p:nvPr/>
         </p:nvSpPr>
         <p:spPr>
           <a:xfrm>
-            <a:off x="5852160" y="4956048"/>
-            <a:ext cx="3429000" cy="256032"/>
+            <a:off x="3794760" y="4910328"/>
+            <a:ext cx="3931920" cy="256032"/>
           </a:xfrm>
           <a:prstGeom prst="rect">
             <a:avLst/>
@@ -9432,7 +9696,7 @@
             <a:r>
               <a:rPr lang="en-US" sz="1000" b="1" spc="300" kern="0" dirty="0">
                 <a:solidFill>
-                  <a:srgbClr val="00C2CB"/>
+                  <a:srgbClr val="004AAD"/>
                 </a:solidFill>
               </a:rPr>
               <a:t>E-MAIL</a:t>
@@ -9443,14 +9707,14 @@
       </p:sp>
       <p:sp>
         <p:nvSpPr>
-          <p:cNvPr id="34" name="Text 29"/>
+          <p:cNvPr id="34" name="Text 30"/>
           <p:cNvSpPr txBox="1"/>
           <p:nvPr/>
         </p:nvSpPr>
         <p:spPr>
           <a:xfrm>
-            <a:off x="5852160" y="5230368"/>
-            <a:ext cx="3429000" cy="365760"/>
+            <a:off x="3794760" y="5184648"/>
+            <a:ext cx="3931920" cy="365760"/>
           </a:xfrm>
           <a:prstGeom prst="rect">
             <a:avLst/>
@@ -9468,7 +9732,7 @@
             <a:r>
               <a:rPr lang="en-US" sz="1500" dirty="0">
                 <a:solidFill>
-                  <a:srgbClr val="FFFFFF"/>
+                  <a:srgbClr val="0D1150"/>
                 </a:solidFill>
               </a:rPr>
               <a:t>contato@grupodesenvolve.com.br</a:t>
@@ -9479,14 +9743,14 @@
       </p:sp>
       <p:sp>
         <p:nvSpPr>
-          <p:cNvPr id="35" name="Text 30"/>
+          <p:cNvPr id="35" name="Text 31"/>
           <p:cNvSpPr txBox="1"/>
           <p:nvPr/>
         </p:nvSpPr>
         <p:spPr>
           <a:xfrm>
-            <a:off x="9509760" y="4956048"/>
-            <a:ext cx="1737360" cy="256032"/>
+            <a:off x="8046720" y="4910328"/>
+            <a:ext cx="2194560" cy="256032"/>
           </a:xfrm>
           <a:prstGeom prst="rect">
             <a:avLst/>
@@ -9504,7 +9768,7 @@
             <a:r>
               <a:rPr lang="en-US" sz="1000" b="1" spc="300" kern="0" dirty="0">
                 <a:solidFill>
-                  <a:srgbClr val="00C2CB"/>
+                  <a:srgbClr val="004AAD"/>
                 </a:solidFill>
               </a:rPr>
               <a:t>INSTAGRAM</a:t>
@@ -9515,14 +9779,14 @@
       </p:sp>
       <p:sp>
         <p:nvSpPr>
-          <p:cNvPr id="36" name="Text 31"/>
+          <p:cNvPr id="36" name="Text 32"/>
           <p:cNvSpPr txBox="1"/>
           <p:nvPr/>
         </p:nvSpPr>
         <p:spPr>
           <a:xfrm>
-            <a:off x="9509760" y="5230368"/>
-            <a:ext cx="1737360" cy="365760"/>
+            <a:off x="8046720" y="5184648"/>
+            <a:ext cx="2194560" cy="365760"/>
           </a:xfrm>
           <a:prstGeom prst="rect">
             <a:avLst/>
@@ -9540,7 +9804,7 @@
             <a:r>
               <a:rPr lang="en-US" sz="1500" dirty="0">
                 <a:solidFill>
-                  <a:srgbClr val="FFFFFF"/>
+                  <a:srgbClr val="0D1150"/>
                 </a:solidFill>
               </a:rPr>
               <a:t>@grupodsve</a:t>
@@ -9551,13 +9815,13 @@
       </p:sp>
       <p:sp>
         <p:nvSpPr>
-          <p:cNvPr id="37" name="Text 32"/>
+          <p:cNvPr id="37" name="Text 33"/>
           <p:cNvSpPr txBox="1"/>
           <p:nvPr/>
         </p:nvSpPr>
         <p:spPr>
           <a:xfrm>
-            <a:off x="548640" y="6263640"/>
+            <a:off x="548640" y="5897880"/>
             <a:ext cx="11064240" cy="274320"/>
           </a:xfrm>
           <a:prstGeom prst="rect">
@@ -9576,12 +9840,60 @@
             <a:r>
               <a:rPr lang="en-US" sz="1000" dirty="0">
                 <a:solidFill>
-                  <a:srgbClr val="B8C4EC"/>
+                  <a:srgbClr val="4A5578"/>
                 </a:solidFill>
               </a:rPr>
               <a:t>Desenvolve Consultoria Ltda. · CNPJ 27.594.121/0001-65 · Ribeirão Preto/SP</a:t>
             </a:r>
             <a:endParaRPr lang="en-US" sz="1000" dirty="0"/>
+          </a:p>
+        </p:txBody>
+      </p:sp>
+      <p:sp>
+        <p:nvSpPr>
+          <p:cNvPr id="25" name="Slide Number Placeholder 0"/>
+          <p:cNvSpPr>
+            <a:spLocks noGrp="1"/>
+          </p:cNvSpPr>
+          <p:nvPr>
+            <p:ph type="sldNum" sz="quarter" idx="4294967295"/>
+          </p:nvPr>
+        </p:nvSpPr>
+        <p:spPr>
+          <a:xfrm>
+            <a:off x="11155680" y="6355080"/>
+            <a:ext cx="502920" cy="274320"/>
+          </a:xfrm>
+          <a:prstGeom prst="rect">
+            <a:avLst/>
+          </a:prstGeom>
+          <a:extLst>
+            <a:ext uri="{C572A759-6A51-4108-AA02-DFA0A04FC94B}">
+              <ma14:wrappingTextBoxFlag xmlns:ma14="http://schemas.microsoft.com/office/mac/drawingml/2011/main" val="0"/>
+            </a:ext>
+          </a:extLst>
+        </p:spPr>
+        <p:txBody>
+          <a:bodyPr/>
+          <a:lstStyle>
+            <a:lvl1pPr>
+              <a:defRPr sz="1000">
+                <a:solidFill>
+                  <a:srgbClr val="4A5578"/>
+                </a:solidFill>
+                <a:latin typeface="Montserrat"/>
+                <a:ea typeface="Montserrat"/>
+                <a:cs typeface="Montserrat"/>
+              </a:defRPr>
+            </a:lvl1pPr>
+          </a:lstStyle>
+          <a:p>
+            <a:pPr algn="r"/>
+            <a:fld id="{F7021451-1387-4CA6-816F-3879F97B5CBC}" type="slidenum">
+              <a:rPr b="0" lang="en-US"/>
+              <a:t>9</a:t>
+            </a:fld>
+            <a:endParaRPr lang="en-US"/>
           </a:p>
         </p:txBody>
       </p:sp>
@@ -9625,13 +9937,13 @@
         <a:srgbClr val="0A2E7A"/>
       </a:accent5>
       <a:accent6>
-        <a:srgbClr val="E8EEFB"/>
+        <a:srgbClr val="EEF2FB"/>
       </a:accent6>
       <a:hlink>
-        <a:srgbClr val="00C2CB"/>
+        <a:srgbClr val="004AAD"/>
       </a:hlink>
       <a:folHlink>
-        <a:srgbClr val="7FE3E8"/>
+        <a:srgbClr val="2E6FD8"/>
       </a:folHlink>
     </a:clrScheme>
     <a:fontScheme name="Desenvolve Consultoria">

</xml_diff>

<commit_message>
Apresentação comercial: rodapé só com logomarca discreta; Município e Gestor com inicial maiúscula
Co-Authored-By: Claude Opus 5.5 <noreply@anthropic.com>
Claude-Session: https://claude.ai/code/session_019K4zAb3bJvz8CAJA5zYx7h
</commit_message>
<xml_diff>
--- a/apresentacoes/comercial-consultoria/Apresentacao Comercial - Desenvolve Consultoria.pptx
+++ b/apresentacoes/comercial-consultoria/Apresentacao Comercial - Desenvolve Consultoria.pptx
@@ -115,26 +115,26 @@
   <p:extLst>
     <p:ext uri="{521415D9-36F7-43E2-AB2F-B90AF26B5E84}">
       <p14:sectionLst xmlns:p14="http://schemas.microsoft.com/office/powerpoint/2010/main">
-        <p14:section name="Abertura" id="{a9b26421-5fc8-bc1f-ecec-3da375c4a101}">
+        <p14:section name="Abertura" id="{7734cf6e-3a52-6b1c-d886-4a3cff54c218}">
           <p14:sldIdLst>
             <p14:sldId id="256"/>
           </p14:sldIdLst>
         </p14:section>
-        <p14:section name="O desafio" id="{085bd17b-7397-f39b-a11c-0e3284aabd98}">
+        <p14:section name="O desafio" id="{03069e08-5087-50e4-0f0d-588d815f8f08}">
           <p14:sldIdLst>
             <p14:sldId id="257"/>
             <p14:sldId id="258"/>
             <p14:sldId id="259"/>
           </p14:sldIdLst>
         </p14:section>
-        <p14:section name="A solução" id="{8ddec474-5fad-81a7-5b7d-ee250fad4076}">
+        <p14:section name="A solução" id="{ea749614-1fbd-7f49-889a-943971b76746}">
           <p14:sldIdLst>
             <p14:sldId id="260"/>
             <p14:sldId id="261"/>
             <p14:sldId id="262"/>
           </p14:sldIdLst>
         </p14:section>
-        <p14:section name="Fechamento" id="{c0196886-5a21-5b99-1f9b-50788fce6b64}">
+        <p14:section name="Fechamento" id="{ba0b00ec-b576-e649-cfcf-39c8713b989e}">
           <p14:sldIdLst>
             <p14:sldId id="263"/>
             <p14:sldId id="264"/>
@@ -877,7 +877,7 @@
           <a:p>
             <a:r>
               <a:rPr lang="en-US" dirty="0"/>
-              <a:t>Saldo: R$ 51.674.490.522,78 (InvestSUS, Painel de Saldos, consulta em out/2026). Receita própria: média de 22,2% em 2025 contra mínimo de 15%; R$ 57,4 bi acima do piso em 2024 (CNM/SIOPS). Mensagem: o município banca a saúde com recurso próprio enquanto o recurso vinculado fica parado.</a:t>
+              <a:t>Saldo: R$ 51.674.490.522,78 (InvestSUS, Painel de Saldos, consulta em out/2026). Receita própria: média de 22,2% em 2025 contra mínimo de 15%; R$ 57,4 bi acima do piso em 2024 (CNM/SIOPS). Mensagem: o Município banca a saúde com recurso próprio enquanto o recurso vinculado fica parado.</a:t>
             </a:r>
             <a:endParaRPr lang="en-US" dirty="0"/>
           </a:p>
@@ -1141,7 +1141,7 @@
           <a:p>
             <a:r>
               <a:rPr lang="en-US" dirty="0"/>
-              <a:t>Atualize o número de municípios atendidos sempre que mudar.</a:t>
+              <a:t>Atualize o número de Municípios atendidos sempre que mudar.</a:t>
             </a:r>
             <a:endParaRPr lang="en-US" dirty="0"/>
           </a:p>
@@ -1317,7 +1317,7 @@
           <a:p>
             <a:r>
               <a:rPr lang="en-US" dirty="0"/>
-              <a:t>Clique no botão para abrir o Visão 360 em nova aba e mostrar os números do município do cliente. Link: https://www.visao360saude.com.br/login.php</a:t>
+              <a:t>Clique no botão para abrir o Visão 360 em nova aba e mostrar os números do Município do cliente. Link: https://www.visao360saude.com.br/login.php</a:t>
             </a:r>
             <a:endParaRPr lang="en-US" dirty="0"/>
           </a:p>
@@ -1681,7 +1681,7 @@
       </p:sp>
       <p:pic>
         <p:nvPicPr>
-          <p:cNvPr id="3" name="Image 0" descr="/tmp/claude-0/-home-user/25c0be0f-0a5e-54d0-b86c-4757d56f039f/scratchpad/deck/assets/dsve-branco.png">    </p:cNvPr>
+          <p:cNvPr id="3" name="Image 0" descr="/tmp/claude-0/-home-user/25c0be0f-0a5e-54d0-b86c-4757d56f039f/scratchpad/deck/assets/dsve-branco-suave.png">    </p:cNvPr>
           <p:cNvPicPr>
             <a:picLocks noChangeAspect="1"/>
           </p:cNvPicPr>
@@ -1695,8 +1695,8 @@
         </p:blipFill>
         <p:spPr>
           <a:xfrm>
-            <a:off x="548640" y="6327648"/>
-            <a:ext cx="877824" cy="320040"/>
+            <a:off x="10963656" y="6382512"/>
+            <a:ext cx="676656" cy="246888"/>
           </a:xfrm>
           <a:prstGeom prst="rect">
             <a:avLst/>
@@ -1707,47 +1707,8 @@
         <p:nvSpPr>
           <p:cNvPr id="4" name="Text 1"/>
           <p:cNvSpPr/>
-          <p:nvPr/>
-        </p:nvSpPr>
-        <p:spPr>
-          <a:xfrm>
-            <a:off x="1600200" y="6355080"/>
-            <a:ext cx="5486400" cy="274320"/>
-          </a:xfrm>
-          <a:prstGeom prst="rect">
-            <a:avLst/>
-          </a:prstGeom>
-          <a:noFill/>
-          <a:ln/>
-        </p:spPr>
-        <p:txBody>
-          <a:bodyPr wrap="square" lIns="0" tIns="0" rIns="0" bIns="0" rtlCol="0" anchor="ctr"/>
-          <a:lstStyle/>
-          <a:p>
-            <a:pPr indent="0" marL="0">
-              <a:buNone/>
-            </a:pPr>
-            <a:r>
-              <a:rPr lang="en-US" sz="1000" dirty="0">
-                <a:solidFill>
-                  <a:srgbClr val="B8C4EC"/>
-                </a:solidFill>
-                <a:latin typeface="Montserrat" pitchFamily="34" charset="0"/>
-                <a:ea typeface="Montserrat" pitchFamily="34" charset="-122"/>
-                <a:cs typeface="Montserrat" pitchFamily="34" charset="-120"/>
-              </a:rPr>
-              <a:t>Desenvolve Consultoria · Grupo Desenvolve</a:t>
-            </a:r>
-            <a:endParaRPr lang="en-US" sz="1000" dirty="0"/>
-          </a:p>
-        </p:txBody>
-      </p:sp>
-      <p:sp>
-        <p:nvSpPr>
-          <p:cNvPr id="5" name="Text 2"/>
-          <p:cNvSpPr/>
           <p:nvPr>
-            <p:ph idx="103" type="body" hasCustomPrompt="1"/>
+            <p:ph idx="102" type="body" hasCustomPrompt="1"/>
           </p:nvPr>
         </p:nvSpPr>
         <p:spPr>
@@ -1786,10 +1747,10 @@
       </p:sp>
       <p:sp>
         <p:nvSpPr>
-          <p:cNvPr id="6" name="Text 2"/>
+          <p:cNvPr id="5" name="Text 1"/>
           <p:cNvSpPr/>
           <p:nvPr>
-            <p:ph idx="104" type="title" hasCustomPrompt="1"/>
+            <p:ph idx="103" type="title" hasCustomPrompt="1"/>
           </p:nvPr>
         </p:nvSpPr>
         <p:spPr>
@@ -1823,54 +1784,6 @@
               <a:buNone/>
             </a:pPr>
             <a:endParaRPr lang="en-US" sz="3000" dirty="0"/>
-          </a:p>
-        </p:txBody>
-      </p:sp>
-      <p:sp>
-        <p:nvSpPr>
-          <p:cNvPr id="25" name="Slide Number Placeholder 0"/>
-          <p:cNvSpPr>
-            <a:spLocks noGrp="1"/>
-          </p:cNvSpPr>
-          <p:nvPr>
-            <p:ph type="sldNum" sz="quarter" idx="4294967295"/>
-          </p:nvPr>
-        </p:nvSpPr>
-        <p:spPr>
-          <a:xfrm>
-            <a:off x="11155680" y="6355080"/>
-            <a:ext cx="502920" cy="274320"/>
-          </a:xfrm>
-          <a:prstGeom prst="rect">
-            <a:avLst/>
-          </a:prstGeom>
-          <a:extLst>
-            <a:ext uri="{C572A759-6A51-4108-AA02-DFA0A04FC94B}">
-              <ma14:wrappingTextBoxFlag xmlns:ma14="http://schemas.microsoft.com/office/mac/drawingml/2011/main" val="0"/>
-            </a:ext>
-          </a:extLst>
-        </p:spPr>
-        <p:txBody>
-          <a:bodyPr/>
-          <a:lstStyle>
-            <a:lvl1pPr>
-              <a:defRPr sz="1000">
-                <a:solidFill>
-                  <a:srgbClr val="B8C4EC"/>
-                </a:solidFill>
-                <a:latin typeface="Montserrat"/>
-                <a:ea typeface="Montserrat"/>
-                <a:cs typeface="Montserrat"/>
-              </a:defRPr>
-            </a:lvl1pPr>
-          </a:lstStyle>
-          <a:p>
-            <a:pPr algn="r"/>
-            <a:fld id="{F7021451-1387-4CA6-816F-3879F97B5CBC}" type="slidenum">
-              <a:rPr b="0" lang="en-US"/>
-              <a:t>1003</a:t>
-            </a:fld>
-            <a:endParaRPr lang="en-US"/>
           </a:p>
         </p:txBody>
       </p:sp>
@@ -1908,7 +1821,7 @@
       </p:grpSpPr>
       <p:pic>
         <p:nvPicPr>
-          <p:cNvPr id="2" name="Image 0" descr="/tmp/claude-0/-home-user/25c0be0f-0a5e-54d0-b86c-4757d56f039f/scratchpad/deck/assets/dsve-azul.png">    </p:cNvPr>
+          <p:cNvPr id="2" name="Image 0" descr="/tmp/claude-0/-home-user/25c0be0f-0a5e-54d0-b86c-4757d56f039f/scratchpad/deck/assets/dsve-azul-suave.png">    </p:cNvPr>
           <p:cNvPicPr>
             <a:picLocks noChangeAspect="1"/>
           </p:cNvPicPr>
@@ -1922,8 +1835,8 @@
         </p:blipFill>
         <p:spPr>
           <a:xfrm>
-            <a:off x="548640" y="6327648"/>
-            <a:ext cx="877824" cy="320040"/>
+            <a:off x="10963656" y="6382512"/>
+            <a:ext cx="676656" cy="246888"/>
           </a:xfrm>
           <a:prstGeom prst="rect">
             <a:avLst/>
@@ -1934,47 +1847,8 @@
         <p:nvSpPr>
           <p:cNvPr id="3" name="Text 0"/>
           <p:cNvSpPr/>
-          <p:nvPr/>
-        </p:nvSpPr>
-        <p:spPr>
-          <a:xfrm>
-            <a:off x="1600200" y="6355080"/>
-            <a:ext cx="5486400" cy="274320"/>
-          </a:xfrm>
-          <a:prstGeom prst="rect">
-            <a:avLst/>
-          </a:prstGeom>
-          <a:noFill/>
-          <a:ln/>
-        </p:spPr>
-        <p:txBody>
-          <a:bodyPr wrap="square" lIns="0" tIns="0" rIns="0" bIns="0" rtlCol="0" anchor="ctr"/>
-          <a:lstStyle/>
-          <a:p>
-            <a:pPr indent="0" marL="0">
-              <a:buNone/>
-            </a:pPr>
-            <a:r>
-              <a:rPr lang="en-US" sz="1000" dirty="0">
-                <a:solidFill>
-                  <a:srgbClr val="4A5578"/>
-                </a:solidFill>
-                <a:latin typeface="Montserrat" pitchFamily="34" charset="0"/>
-                <a:ea typeface="Montserrat" pitchFamily="34" charset="-122"/>
-                <a:cs typeface="Montserrat" pitchFamily="34" charset="-120"/>
-              </a:rPr>
-              <a:t>Desenvolve Consultoria · Grupo Desenvolve</a:t>
-            </a:r>
-            <a:endParaRPr lang="en-US" sz="1000" dirty="0"/>
-          </a:p>
-        </p:txBody>
-      </p:sp>
-      <p:sp>
-        <p:nvSpPr>
-          <p:cNvPr id="4" name="Text 1"/>
-          <p:cNvSpPr/>
           <p:nvPr>
-            <p:ph idx="102" type="body" hasCustomPrompt="1"/>
+            <p:ph idx="101" type="body" hasCustomPrompt="1"/>
           </p:nvPr>
         </p:nvSpPr>
         <p:spPr>
@@ -2013,10 +1887,10 @@
       </p:sp>
       <p:sp>
         <p:nvSpPr>
-          <p:cNvPr id="5" name="Text 1"/>
+          <p:cNvPr id="4" name="Text 0"/>
           <p:cNvSpPr/>
           <p:nvPr>
-            <p:ph idx="103" type="title" hasCustomPrompt="1"/>
+            <p:ph idx="102" type="title" hasCustomPrompt="1"/>
           </p:nvPr>
         </p:nvSpPr>
         <p:spPr>
@@ -2050,54 +1924,6 @@
               <a:buNone/>
             </a:pPr>
             <a:endParaRPr lang="en-US" sz="3000" dirty="0"/>
-          </a:p>
-        </p:txBody>
-      </p:sp>
-      <p:sp>
-        <p:nvSpPr>
-          <p:cNvPr id="25" name="Slide Number Placeholder 0"/>
-          <p:cNvSpPr>
-            <a:spLocks noGrp="1"/>
-          </p:cNvSpPr>
-          <p:nvPr>
-            <p:ph type="sldNum" sz="quarter" idx="4294967295"/>
-          </p:nvPr>
-        </p:nvSpPr>
-        <p:spPr>
-          <a:xfrm>
-            <a:off x="11155680" y="6355080"/>
-            <a:ext cx="502920" cy="274320"/>
-          </a:xfrm>
-          <a:prstGeom prst="rect">
-            <a:avLst/>
-          </a:prstGeom>
-          <a:extLst>
-            <a:ext uri="{C572A759-6A51-4108-AA02-DFA0A04FC94B}">
-              <ma14:wrappingTextBoxFlag xmlns:ma14="http://schemas.microsoft.com/office/mac/drawingml/2011/main" val="0"/>
-            </a:ext>
-          </a:extLst>
-        </p:spPr>
-        <p:txBody>
-          <a:bodyPr/>
-          <a:lstStyle>
-            <a:lvl1pPr>
-              <a:defRPr sz="1000">
-                <a:solidFill>
-                  <a:srgbClr val="4A5578"/>
-                </a:solidFill>
-                <a:latin typeface="Montserrat"/>
-                <a:ea typeface="Montserrat"/>
-                <a:cs typeface="Montserrat"/>
-              </a:defRPr>
-            </a:lvl1pPr>
-          </a:lstStyle>
-          <a:p>
-            <a:pPr algn="r"/>
-            <a:fld id="{F7021451-1387-4CA6-816F-3879F97B5CBC}" type="slidenum">
-              <a:rPr b="0" lang="en-US"/>
-              <a:t>1004</a:t>
-            </a:fld>
-            <a:endParaRPr lang="en-US"/>
           </a:p>
         </p:txBody>
       </p:sp>
@@ -2126,54 +1952,6 @@
           <a:chExt cx="0" cy="0"/>
         </a:xfrm>
       </p:grpSpPr>
-      <p:sp>
-        <p:nvSpPr>
-          <p:cNvPr id="25" name="Slide Number Placeholder 0"/>
-          <p:cNvSpPr>
-            <a:spLocks noGrp="1"/>
-          </p:cNvSpPr>
-          <p:nvPr>
-            <p:ph type="sldNum" sz="quarter" idx="4294967295"/>
-          </p:nvPr>
-        </p:nvSpPr>
-        <p:spPr>
-          <a:xfrm>
-            <a:off x="11155680" y="6355080"/>
-            <a:ext cx="502920" cy="274320"/>
-          </a:xfrm>
-          <a:prstGeom prst="rect">
-            <a:avLst/>
-          </a:prstGeom>
-          <a:extLst>
-            <a:ext uri="{C572A759-6A51-4108-AA02-DFA0A04FC94B}">
-              <ma14:wrappingTextBoxFlag xmlns:ma14="http://schemas.microsoft.com/office/mac/drawingml/2011/main" val="0"/>
-            </a:ext>
-          </a:extLst>
-        </p:spPr>
-        <p:txBody>
-          <a:bodyPr/>
-          <a:lstStyle>
-            <a:lvl1pPr>
-              <a:defRPr sz="1000">
-                <a:solidFill>
-                  <a:srgbClr val="B8C4EC"/>
-                </a:solidFill>
-                <a:latin typeface="Montserrat"/>
-                <a:ea typeface="Montserrat"/>
-                <a:cs typeface="Montserrat"/>
-              </a:defRPr>
-            </a:lvl1pPr>
-          </a:lstStyle>
-          <a:p>
-            <a:pPr algn="r"/>
-            <a:fld id="{F7021451-1387-4CA6-816F-3879F97B5CBC}" type="slidenum">
-              <a:rPr b="0" lang="en-US"/>
-              <a:t>null</a:t>
-            </a:fld>
-            <a:endParaRPr lang="en-US"/>
-          </a:p>
-        </p:txBody>
-      </p:sp>
     </p:spTree>
   </p:cSld>
   <p:clrMap bg1="lt1" tx1="dk1" bg2="lt2" tx2="dk2" accent1="accent1" accent2="accent2" accent3="accent3" accent4="accent4" accent5="accent5" accent6="accent6" hlink="hlink" folHlink="folHlink"/>
@@ -2599,7 +2377,7 @@
                 <a:ea typeface="Raleway" pitchFamily="34" charset="-122"/>
                 <a:cs typeface="Raleway" pitchFamily="34" charset="-120"/>
               </a:rPr>
-              <a:t> para a saúde do seu município</a:t>
+              <a:t> para a saúde do seu Município</a:t>
             </a:r>
             <a:endParaRPr lang="en-US" sz="3800" dirty="0"/>
           </a:p>
@@ -2728,10 +2506,10 @@
       </p:grpSpPr>
       <p:sp>
         <p:nvSpPr>
-          <p:cNvPr id="2" name="Text 1"/>
+          <p:cNvPr id="2" name="Text 0"/>
           <p:cNvSpPr/>
           <p:nvPr>
-            <p:ph idx="102" type="body" hasCustomPrompt="1"/>
+            <p:ph idx="101" type="body" hasCustomPrompt="1"/>
           </p:nvPr>
         </p:nvSpPr>
         <p:spPr>
@@ -2769,10 +2547,10 @@
       </p:sp>
       <p:sp>
         <p:nvSpPr>
-          <p:cNvPr id="3" name="Text 1"/>
+          <p:cNvPr id="3" name="Text 0"/>
           <p:cNvSpPr/>
           <p:nvPr>
-            <p:ph idx="103" type="title" hasCustomPrompt="1"/>
+            <p:ph idx="102" type="title" hasCustomPrompt="1"/>
           </p:nvPr>
         </p:nvSpPr>
         <p:spPr>
@@ -2816,7 +2594,7 @@
                 <a:ea typeface="Raleway" pitchFamily="34" charset="-122"/>
                 <a:cs typeface="Raleway" pitchFamily="34" charset="-120"/>
               </a:rPr>
-              <a:t>nem sempre está onde o município precisa</a:t>
+              <a:t>nem sempre está onde o Município precisa</a:t>
             </a:r>
             <a:endParaRPr lang="en-US" sz="3000" dirty="0"/>
           </a:p>
@@ -2968,7 +2746,7 @@
                   <a:srgbClr val="DCE6FA"/>
                 </a:solidFill>
               </a:rPr>
-              <a:t>O recurso federal e estadual chega vinculado a blocos e finalidades definidos fora do município, que nem sempre atendem às necessidades locais. Enquanto ele se acumula em conta, o recurso próprio é pressionado a cobrir o restante.</a:t>
+              <a:t>O recurso federal e estadual chega vinculado a blocos e finalidades definidos fora do Município, que nem sempre atendem às necessidades locais. Enquanto ele se acumula em conta, o recurso próprio é pressionado a cobrir o restante.</a:t>
             </a:r>
             <a:endParaRPr lang="en-US" sz="1400" dirty="0"/>
           </a:p>
@@ -3067,7 +2845,7 @@
                   <a:srgbClr val="0D1150"/>
                 </a:solidFill>
               </a:rPr>
-              <a:t>Receita própria aplicada em saúde pelos municípios, 2025</a:t>
+              <a:t>Receita própria aplicada em saúde pelos Municípios, 2025</a:t>
             </a:r>
             <a:endParaRPr lang="en-US" sz="1500" dirty="0"/>
           </a:p>
@@ -3130,7 +2908,7 @@
                   <a:srgbClr val="0D1150"/>
                 </a:solidFill>
               </a:rPr>
-              <a:t> acima do piso constitucional, aplicados pelos municípios em 2024</a:t>
+              <a:t> acima do piso constitucional, aplicados pelos Municípios em 2024</a:t>
             </a:r>
             <a:endParaRPr lang="en-US" sz="1600" dirty="0"/>
           </a:p>
@@ -3169,54 +2947,6 @@
               <a:t>Fonte: CNM, a partir de dados do SIOPS (2024 e 2025).</a:t>
             </a:r>
             <a:endParaRPr lang="en-US" sz="1000" dirty="0"/>
-          </a:p>
-        </p:txBody>
-      </p:sp>
-      <p:sp>
-        <p:nvSpPr>
-          <p:cNvPr id="25" name="Slide Number Placeholder 0"/>
-          <p:cNvSpPr>
-            <a:spLocks noGrp="1"/>
-          </p:cNvSpPr>
-          <p:nvPr>
-            <p:ph type="sldNum" sz="quarter" idx="4294967295"/>
-          </p:nvPr>
-        </p:nvSpPr>
-        <p:spPr>
-          <a:xfrm>
-            <a:off x="11155680" y="6355080"/>
-            <a:ext cx="502920" cy="274320"/>
-          </a:xfrm>
-          <a:prstGeom prst="rect">
-            <a:avLst/>
-          </a:prstGeom>
-          <a:extLst>
-            <a:ext uri="{C572A759-6A51-4108-AA02-DFA0A04FC94B}">
-              <ma14:wrappingTextBoxFlag xmlns:ma14="http://schemas.microsoft.com/office/mac/drawingml/2011/main" val="0"/>
-            </a:ext>
-          </a:extLst>
-        </p:spPr>
-        <p:txBody>
-          <a:bodyPr/>
-          <a:lstStyle>
-            <a:lvl1pPr>
-              <a:defRPr sz="1000">
-                <a:solidFill>
-                  <a:srgbClr val="4A5578"/>
-                </a:solidFill>
-                <a:latin typeface="Montserrat"/>
-                <a:ea typeface="Montserrat"/>
-                <a:cs typeface="Montserrat"/>
-              </a:defRPr>
-            </a:lvl1pPr>
-          </a:lstStyle>
-          <a:p>
-            <a:pPr algn="r"/>
-            <a:fld id="{F7021451-1387-4CA6-816F-3879F97B5CBC}" type="slidenum">
-              <a:rPr b="0" lang="en-US"/>
-              <a:t>2</a:t>
-            </a:fld>
-            <a:endParaRPr lang="en-US"/>
           </a:p>
         </p:txBody>
       </p:sp>
@@ -3247,10 +2977,10 @@
       </p:grpSpPr>
       <p:sp>
         <p:nvSpPr>
-          <p:cNvPr id="2" name="Text 1"/>
+          <p:cNvPr id="2" name="Text 0"/>
           <p:cNvSpPr/>
           <p:nvPr>
-            <p:ph idx="102" type="body" hasCustomPrompt="1"/>
+            <p:ph idx="101" type="body" hasCustomPrompt="1"/>
           </p:nvPr>
         </p:nvSpPr>
         <p:spPr>
@@ -3288,10 +3018,10 @@
       </p:sp>
       <p:sp>
         <p:nvSpPr>
-          <p:cNvPr id="3" name="Text 1"/>
+          <p:cNvPr id="3" name="Text 0"/>
           <p:cNvSpPr/>
           <p:nvPr>
-            <p:ph idx="103" type="title" hasCustomPrompt="1"/>
+            <p:ph idx="102" type="title" hasCustomPrompt="1"/>
           </p:nvPr>
         </p:nvSpPr>
         <p:spPr>
@@ -4125,57 +3855,9 @@
                   <a:srgbClr val="004AAD"/>
                 </a:solidFill>
               </a:rPr>
-              <a:t>Cada suporte que falta é um ponto de risco para a gestão e para o gestor.</a:t>
+              <a:t>Cada suporte que falta é um ponto de risco para a gestão e para o Gestor.</a:t>
             </a:r>
             <a:endParaRPr lang="en-US" sz="1400" dirty="0"/>
-          </a:p>
-        </p:txBody>
-      </p:sp>
-      <p:sp>
-        <p:nvSpPr>
-          <p:cNvPr id="25" name="Slide Number Placeholder 0"/>
-          <p:cNvSpPr>
-            <a:spLocks noGrp="1"/>
-          </p:cNvSpPr>
-          <p:nvPr>
-            <p:ph type="sldNum" sz="quarter" idx="4294967295"/>
-          </p:nvPr>
-        </p:nvSpPr>
-        <p:spPr>
-          <a:xfrm>
-            <a:off x="11155680" y="6355080"/>
-            <a:ext cx="502920" cy="274320"/>
-          </a:xfrm>
-          <a:prstGeom prst="rect">
-            <a:avLst/>
-          </a:prstGeom>
-          <a:extLst>
-            <a:ext uri="{C572A759-6A51-4108-AA02-DFA0A04FC94B}">
-              <ma14:wrappingTextBoxFlag xmlns:ma14="http://schemas.microsoft.com/office/mac/drawingml/2011/main" val="0"/>
-            </a:ext>
-          </a:extLst>
-        </p:spPr>
-        <p:txBody>
-          <a:bodyPr/>
-          <a:lstStyle>
-            <a:lvl1pPr>
-              <a:defRPr sz="1000">
-                <a:solidFill>
-                  <a:srgbClr val="4A5578"/>
-                </a:solidFill>
-                <a:latin typeface="Montserrat"/>
-                <a:ea typeface="Montserrat"/>
-                <a:cs typeface="Montserrat"/>
-              </a:defRPr>
-            </a:lvl1pPr>
-          </a:lstStyle>
-          <a:p>
-            <a:pPr algn="r"/>
-            <a:fld id="{F7021451-1387-4CA6-816F-3879F97B5CBC}" type="slidenum">
-              <a:rPr b="0" lang="en-US"/>
-              <a:t>3</a:t>
-            </a:fld>
-            <a:endParaRPr lang="en-US"/>
           </a:p>
         </p:txBody>
       </p:sp>
@@ -4206,10 +3888,10 @@
       </p:grpSpPr>
       <p:sp>
         <p:nvSpPr>
-          <p:cNvPr id="2" name="Text 2"/>
+          <p:cNvPr id="2" name="Text 1"/>
           <p:cNvSpPr/>
           <p:nvPr>
-            <p:ph idx="103" type="body" hasCustomPrompt="1"/>
+            <p:ph idx="102" type="body" hasCustomPrompt="1"/>
           </p:nvPr>
         </p:nvSpPr>
         <p:spPr>
@@ -4247,10 +3929,10 @@
       </p:sp>
       <p:sp>
         <p:nvSpPr>
-          <p:cNvPr id="3" name="Text 2"/>
+          <p:cNvPr id="3" name="Text 1"/>
           <p:cNvSpPr/>
           <p:nvPr>
-            <p:ph idx="104" type="title" hasCustomPrompt="1"/>
+            <p:ph idx="103" type="title" hasCustomPrompt="1"/>
           </p:nvPr>
         </p:nvSpPr>
         <p:spPr>
@@ -4294,7 +3976,7 @@
                 <a:ea typeface="Raleway" pitchFamily="34" charset="-122"/>
                 <a:cs typeface="Raleway" pitchFamily="34" charset="-120"/>
               </a:rPr>
-              <a:t>para o município e para o gestor</a:t>
+              <a:t>para o Município e para o Gestor</a:t>
             </a:r>
             <a:endParaRPr lang="en-US" sz="3000" dirty="0"/>
           </a:p>
@@ -4594,7 +4276,7 @@
                   <a:srgbClr val="B8C4EC"/>
                 </a:solidFill>
               </a:rPr>
-              <a:t>Órgãos de controle apontam falhas, e o gestor responde pessoalmente por elas.</a:t>
+              <a:t>Órgãos de controle apontam falhas, e o Gestor responde pessoalmente por elas.</a:t>
             </a:r>
             <a:endParaRPr lang="en-US" sz="1400" dirty="0"/>
           </a:p>
@@ -4933,54 +4615,6 @@
               <a:t>Referências: Portaria GM/MS nº 3.493/2024 (cofinanciamento da APS); Lei Complementar nº 141/2012 (RAG ao Conselho de Saúde até 30 de março).</a:t>
             </a:r>
             <a:endParaRPr lang="en-US" sz="1000" dirty="0"/>
-          </a:p>
-        </p:txBody>
-      </p:sp>
-      <p:sp>
-        <p:nvSpPr>
-          <p:cNvPr id="25" name="Slide Number Placeholder 0"/>
-          <p:cNvSpPr>
-            <a:spLocks noGrp="1"/>
-          </p:cNvSpPr>
-          <p:nvPr>
-            <p:ph type="sldNum" sz="quarter" idx="4294967295"/>
-          </p:nvPr>
-        </p:nvSpPr>
-        <p:spPr>
-          <a:xfrm>
-            <a:off x="11155680" y="6355080"/>
-            <a:ext cx="502920" cy="274320"/>
-          </a:xfrm>
-          <a:prstGeom prst="rect">
-            <a:avLst/>
-          </a:prstGeom>
-          <a:extLst>
-            <a:ext uri="{C572A759-6A51-4108-AA02-DFA0A04FC94B}">
-              <ma14:wrappingTextBoxFlag xmlns:ma14="http://schemas.microsoft.com/office/mac/drawingml/2011/main" val="0"/>
-            </a:ext>
-          </a:extLst>
-        </p:spPr>
-        <p:txBody>
-          <a:bodyPr/>
-          <a:lstStyle>
-            <a:lvl1pPr>
-              <a:defRPr sz="1000">
-                <a:solidFill>
-                  <a:srgbClr val="B8C4EC"/>
-                </a:solidFill>
-                <a:latin typeface="Montserrat"/>
-                <a:ea typeface="Montserrat"/>
-                <a:cs typeface="Montserrat"/>
-              </a:defRPr>
-            </a:lvl1pPr>
-          </a:lstStyle>
-          <a:p>
-            <a:pPr algn="r"/>
-            <a:fld id="{F7021451-1387-4CA6-816F-3879F97B5CBC}" type="slidenum">
-              <a:rPr b="0" lang="en-US"/>
-              <a:t>4</a:t>
-            </a:fld>
-            <a:endParaRPr lang="en-US"/>
           </a:p>
         </p:txBody>
       </p:sp>
@@ -5011,10 +4645,10 @@
       </p:grpSpPr>
       <p:sp>
         <p:nvSpPr>
-          <p:cNvPr id="2" name="Text 1"/>
+          <p:cNvPr id="2" name="Text 0"/>
           <p:cNvSpPr/>
           <p:nvPr>
-            <p:ph idx="102" type="body" hasCustomPrompt="1"/>
+            <p:ph idx="101" type="body" hasCustomPrompt="1"/>
           </p:nvPr>
         </p:nvSpPr>
         <p:spPr>
@@ -5052,10 +4686,10 @@
       </p:sp>
       <p:sp>
         <p:nvSpPr>
-          <p:cNvPr id="3" name="Text 1"/>
+          <p:cNvPr id="3" name="Text 0"/>
           <p:cNvSpPr/>
           <p:nvPr>
-            <p:ph idx="103" type="title" hasCustomPrompt="1"/>
+            <p:ph idx="102" type="title" hasCustomPrompt="1"/>
           </p:nvPr>
         </p:nvSpPr>
         <p:spPr>
@@ -5210,7 +4844,7 @@
                   <a:srgbClr val="4A5578"/>
                 </a:solidFill>
               </a:rPr>
-              <a:t>municípios atendidos</a:t>
+              <a:t>Municípios atendidos</a:t>
             </a:r>
             <a:endParaRPr lang="en-US" sz="1400" dirty="0"/>
           </a:p>
@@ -5525,54 +5159,6 @@
           </a:prstGeom>
         </p:spPr>
       </p:pic>
-      <p:sp>
-        <p:nvSpPr>
-          <p:cNvPr id="25" name="Slide Number Placeholder 0"/>
-          <p:cNvSpPr>
-            <a:spLocks noGrp="1"/>
-          </p:cNvSpPr>
-          <p:nvPr>
-            <p:ph type="sldNum" sz="quarter" idx="4294967295"/>
-          </p:nvPr>
-        </p:nvSpPr>
-        <p:spPr>
-          <a:xfrm>
-            <a:off x="11155680" y="6355080"/>
-            <a:ext cx="502920" cy="274320"/>
-          </a:xfrm>
-          <a:prstGeom prst="rect">
-            <a:avLst/>
-          </a:prstGeom>
-          <a:extLst>
-            <a:ext uri="{C572A759-6A51-4108-AA02-DFA0A04FC94B}">
-              <ma14:wrappingTextBoxFlag xmlns:ma14="http://schemas.microsoft.com/office/mac/drawingml/2011/main" val="0"/>
-            </a:ext>
-          </a:extLst>
-        </p:spPr>
-        <p:txBody>
-          <a:bodyPr/>
-          <a:lstStyle>
-            <a:lvl1pPr>
-              <a:defRPr sz="1000">
-                <a:solidFill>
-                  <a:srgbClr val="4A5578"/>
-                </a:solidFill>
-                <a:latin typeface="Montserrat"/>
-                <a:ea typeface="Montserrat"/>
-                <a:cs typeface="Montserrat"/>
-              </a:defRPr>
-            </a:lvl1pPr>
-          </a:lstStyle>
-          <a:p>
-            <a:pPr algn="r"/>
-            <a:fld id="{F7021451-1387-4CA6-816F-3879F97B5CBC}" type="slidenum">
-              <a:rPr b="0" lang="en-US"/>
-              <a:t>5</a:t>
-            </a:fld>
-            <a:endParaRPr lang="en-US"/>
-          </a:p>
-        </p:txBody>
-      </p:sp>
     </p:spTree>
   </p:cSld>
   <p:clrMapOvr>
@@ -5600,10 +5186,10 @@
       </p:grpSpPr>
       <p:sp>
         <p:nvSpPr>
-          <p:cNvPr id="2" name="Text 1"/>
+          <p:cNvPr id="2" name="Text 0"/>
           <p:cNvSpPr/>
           <p:nvPr>
-            <p:ph idx="102" type="body" hasCustomPrompt="1"/>
+            <p:ph idx="101" type="body" hasCustomPrompt="1"/>
           </p:nvPr>
         </p:nvSpPr>
         <p:spPr>
@@ -5641,10 +5227,10 @@
       </p:sp>
       <p:sp>
         <p:nvSpPr>
-          <p:cNvPr id="3" name="Text 1"/>
+          <p:cNvPr id="3" name="Text 0"/>
           <p:cNvSpPr/>
           <p:nvPr>
-            <p:ph idx="103" type="title" hasCustomPrompt="1"/>
+            <p:ph idx="102" type="title" hasCustomPrompt="1"/>
           </p:nvPr>
         </p:nvSpPr>
         <p:spPr>
@@ -5821,7 +5407,7 @@
                   <a:srgbClr val="4A5578"/>
                 </a:solidFill>
               </a:rPr>
-              <a:t>Captação e ampliação de recursos federais e estaduais, com habilitações, programas e propostas técnicas que aumentam o orçamento da saúde do município.</a:t>
+              <a:t>Captação e ampliação de recursos federais e estaduais, com habilitações, programas e propostas técnicas que aumentam o orçamento da saúde do Município.</a:t>
             </a:r>
             <a:endParaRPr lang="en-US" sz="1300" dirty="0"/>
           </a:p>
@@ -5977,7 +5563,7 @@
                   <a:srgbClr val="4A5578"/>
                 </a:solidFill>
               </a:rPr>
-              <a:t>Aplicação e priorização dos recursos vinculados federais e estaduais, liberando o recurso próprio para as necessidades definidas pelo município.</a:t>
+              <a:t>Aplicação e priorização dos recursos vinculados federais e estaduais, liberando o recurso próprio para as necessidades definidas pelo Município.</a:t>
             </a:r>
             <a:endParaRPr lang="en-US" sz="1300" dirty="0"/>
           </a:p>
@@ -6133,7 +5719,7 @@
                   <a:srgbClr val="4A5578"/>
                 </a:solidFill>
               </a:rPr>
-              <a:t>Acompanhamento diário de portarias e publicações do Ministério da Saúde e da Secretaria Estadual, com o impacto para o município, espaço para dúvidas e indicação de providências.</a:t>
+              <a:t>Acompanhamento diário de portarias e publicações do Ministério da Saúde e da Secretaria Estadual, com o impacto para o Município, espaço para dúvidas e indicação de providências.</a:t>
             </a:r>
             <a:endParaRPr lang="en-US" sz="1300" dirty="0"/>
           </a:p>
@@ -6448,54 +6034,6 @@
               <a:t>Apoio técnico-normativo na instrução de processos licitatórios e contratações públicas, na organização de documentos e em subsídios técnicos para respostas a Tribunais de Contas, Ministério Público e demais órgãos de controle.</a:t>
             </a:r>
             <a:endParaRPr lang="en-US" sz="1300" dirty="0"/>
-          </a:p>
-        </p:txBody>
-      </p:sp>
-      <p:sp>
-        <p:nvSpPr>
-          <p:cNvPr id="25" name="Slide Number Placeholder 0"/>
-          <p:cNvSpPr>
-            <a:spLocks noGrp="1"/>
-          </p:cNvSpPr>
-          <p:nvPr>
-            <p:ph type="sldNum" sz="quarter" idx="4294967295"/>
-          </p:nvPr>
-        </p:nvSpPr>
-        <p:spPr>
-          <a:xfrm>
-            <a:off x="11155680" y="6355080"/>
-            <a:ext cx="502920" cy="274320"/>
-          </a:xfrm>
-          <a:prstGeom prst="rect">
-            <a:avLst/>
-          </a:prstGeom>
-          <a:extLst>
-            <a:ext uri="{C572A759-6A51-4108-AA02-DFA0A04FC94B}">
-              <ma14:wrappingTextBoxFlag xmlns:ma14="http://schemas.microsoft.com/office/mac/drawingml/2011/main" val="0"/>
-            </a:ext>
-          </a:extLst>
-        </p:spPr>
-        <p:txBody>
-          <a:bodyPr/>
-          <a:lstStyle>
-            <a:lvl1pPr>
-              <a:defRPr sz="1000">
-                <a:solidFill>
-                  <a:srgbClr val="4A5578"/>
-                </a:solidFill>
-                <a:latin typeface="Montserrat"/>
-                <a:ea typeface="Montserrat"/>
-                <a:cs typeface="Montserrat"/>
-              </a:defRPr>
-            </a:lvl1pPr>
-          </a:lstStyle>
-          <a:p>
-            <a:pPr algn="r"/>
-            <a:fld id="{F7021451-1387-4CA6-816F-3879F97B5CBC}" type="slidenum">
-              <a:rPr b="0" lang="en-US"/>
-              <a:t>6</a:t>
-            </a:fld>
-            <a:endParaRPr lang="en-US"/>
           </a:p>
         </p:txBody>
       </p:sp>
@@ -6526,10 +6064,10 @@
       </p:grpSpPr>
       <p:sp>
         <p:nvSpPr>
-          <p:cNvPr id="2" name="Text 2"/>
+          <p:cNvPr id="2" name="Text 1"/>
           <p:cNvSpPr/>
           <p:nvPr>
-            <p:ph idx="103" type="body" hasCustomPrompt="1"/>
+            <p:ph idx="102" type="body" hasCustomPrompt="1"/>
           </p:nvPr>
         </p:nvSpPr>
         <p:spPr>
@@ -6567,10 +6105,10 @@
       </p:sp>
       <p:sp>
         <p:nvSpPr>
-          <p:cNvPr id="3" name="Text 2"/>
+          <p:cNvPr id="3" name="Text 1"/>
           <p:cNvSpPr/>
           <p:nvPr>
-            <p:ph idx="104" type="title" hasCustomPrompt="1"/>
+            <p:ph idx="103" type="title" hasCustomPrompt="1"/>
           </p:nvPr>
         </p:nvSpPr>
         <p:spPr>
@@ -6650,7 +6188,7 @@
                   <a:srgbClr val="B8C4EC"/>
                 </a:solidFill>
               </a:rPr>
-              <a:t>Dados da saúde do município reunidos em gráficos, relatórios e indicadores-chave, para apoiar decisões estratégicas e o acompanhamento das políticas públicas.</a:t>
+              <a:t>Dados da saúde do Município reunidos em gráficos, relatórios e indicadores-chave, para apoiar decisões estratégicas e o acompanhamento das políticas públicas.</a:t>
             </a:r>
             <a:endParaRPr lang="en-US" sz="1500" dirty="0"/>
           </a:p>
@@ -6710,7 +6248,7 @@
                   <a:srgbClr val="FFFFFF"/>
                 </a:solidFill>
               </a:rPr>
-              <a:t>Indicadores-chave do município</a:t>
+              <a:t>Indicadores-chave do Município</a:t>
             </a:r>
             <a:endParaRPr lang="en-US" sz="1500" dirty="0"/>
           </a:p>
@@ -6964,7 +6502,7 @@
                   </a:extLst>
                 </a:hlinkClick>
               </a:rPr>
-              <a:t>Ver os números do seu município  →</a:t>
+              <a:t>Ver os números do seu Município  →</a:t>
             </a:r>
             <a:endParaRPr lang="en-US" sz="1500" dirty="0"/>
           </a:p>
@@ -7786,54 +7324,6 @@
               <a:t>Imagem ilustrativa</a:t>
             </a:r>
             <a:endParaRPr lang="en-US" sz="1000" dirty="0"/>
-          </a:p>
-        </p:txBody>
-      </p:sp>
-      <p:sp>
-        <p:nvSpPr>
-          <p:cNvPr id="25" name="Slide Number Placeholder 0"/>
-          <p:cNvSpPr>
-            <a:spLocks noGrp="1"/>
-          </p:cNvSpPr>
-          <p:nvPr>
-            <p:ph type="sldNum" sz="quarter" idx="4294967295"/>
-          </p:nvPr>
-        </p:nvSpPr>
-        <p:spPr>
-          <a:xfrm>
-            <a:off x="11155680" y="6355080"/>
-            <a:ext cx="502920" cy="274320"/>
-          </a:xfrm>
-          <a:prstGeom prst="rect">
-            <a:avLst/>
-          </a:prstGeom>
-          <a:extLst>
-            <a:ext uri="{C572A759-6A51-4108-AA02-DFA0A04FC94B}">
-              <ma14:wrappingTextBoxFlag xmlns:ma14="http://schemas.microsoft.com/office/mac/drawingml/2011/main" val="0"/>
-            </a:ext>
-          </a:extLst>
-        </p:spPr>
-        <p:txBody>
-          <a:bodyPr/>
-          <a:lstStyle>
-            <a:lvl1pPr>
-              <a:defRPr sz="1000">
-                <a:solidFill>
-                  <a:srgbClr val="B8C4EC"/>
-                </a:solidFill>
-                <a:latin typeface="Montserrat"/>
-                <a:ea typeface="Montserrat"/>
-                <a:cs typeface="Montserrat"/>
-              </a:defRPr>
-            </a:lvl1pPr>
-          </a:lstStyle>
-          <a:p>
-            <a:pPr algn="r"/>
-            <a:fld id="{F7021451-1387-4CA6-816F-3879F97B5CBC}" type="slidenum">
-              <a:rPr b="0" lang="en-US"/>
-              <a:t>7</a:t>
-            </a:fld>
-            <a:endParaRPr lang="en-US"/>
           </a:p>
         </p:txBody>
       </p:sp>
@@ -7864,10 +7354,10 @@
       </p:grpSpPr>
       <p:sp>
         <p:nvSpPr>
-          <p:cNvPr id="2" name="Text 1"/>
+          <p:cNvPr id="2" name="Text 0"/>
           <p:cNvSpPr/>
           <p:nvPr>
-            <p:ph idx="102" type="body" hasCustomPrompt="1"/>
+            <p:ph idx="101" type="body" hasCustomPrompt="1"/>
           </p:nvPr>
         </p:nvSpPr>
         <p:spPr>
@@ -7905,10 +7395,10 @@
       </p:sp>
       <p:sp>
         <p:nvSpPr>
-          <p:cNvPr id="3" name="Text 1"/>
+          <p:cNvPr id="3" name="Text 0"/>
           <p:cNvSpPr/>
           <p:nvPr>
-            <p:ph idx="103" type="title" hasCustomPrompt="1"/>
+            <p:ph idx="102" type="title" hasCustomPrompt="1"/>
           </p:nvPr>
         </p:nvSpPr>
         <p:spPr>
@@ -7952,7 +7442,7 @@
                 <a:ea typeface="Raleway" pitchFamily="34" charset="-122"/>
                 <a:cs typeface="Raleway" pitchFamily="34" charset="-120"/>
               </a:rPr>
-              <a:t>conforme a necessidade do município</a:t>
+              <a:t>conforme a necessidade do Município</a:t>
             </a:r>
             <a:endParaRPr lang="en-US" sz="3000" dirty="0"/>
           </a:p>
@@ -8565,54 +8055,6 @@
               <a:t>A forma mais completa de apoio à Secretaria.</a:t>
             </a:r>
             <a:endParaRPr lang="en-US" sz="1300" dirty="0"/>
-          </a:p>
-        </p:txBody>
-      </p:sp>
-      <p:sp>
-        <p:nvSpPr>
-          <p:cNvPr id="25" name="Slide Number Placeholder 0"/>
-          <p:cNvSpPr>
-            <a:spLocks noGrp="1"/>
-          </p:cNvSpPr>
-          <p:nvPr>
-            <p:ph type="sldNum" sz="quarter" idx="4294967295"/>
-          </p:nvPr>
-        </p:nvSpPr>
-        <p:spPr>
-          <a:xfrm>
-            <a:off x="11155680" y="6355080"/>
-            <a:ext cx="502920" cy="274320"/>
-          </a:xfrm>
-          <a:prstGeom prst="rect">
-            <a:avLst/>
-          </a:prstGeom>
-          <a:extLst>
-            <a:ext uri="{C572A759-6A51-4108-AA02-DFA0A04FC94B}">
-              <ma14:wrappingTextBoxFlag xmlns:ma14="http://schemas.microsoft.com/office/mac/drawingml/2011/main" val="0"/>
-            </a:ext>
-          </a:extLst>
-        </p:spPr>
-        <p:txBody>
-          <a:bodyPr/>
-          <a:lstStyle>
-            <a:lvl1pPr>
-              <a:defRPr sz="1000">
-                <a:solidFill>
-                  <a:srgbClr val="4A5578"/>
-                </a:solidFill>
-                <a:latin typeface="Montserrat"/>
-                <a:ea typeface="Montserrat"/>
-                <a:cs typeface="Montserrat"/>
-              </a:defRPr>
-            </a:lvl1pPr>
-          </a:lstStyle>
-          <a:p>
-            <a:pPr algn="r"/>
-            <a:fld id="{F7021451-1387-4CA6-816F-3879F97B5CBC}" type="slidenum">
-              <a:rPr b="0" lang="en-US"/>
-              <a:t>8</a:t>
-            </a:fld>
-            <a:endParaRPr lang="en-US"/>
           </a:p>
         </p:txBody>
       </p:sp>
@@ -8643,10 +8085,10 @@
       </p:grpSpPr>
       <p:sp>
         <p:nvSpPr>
-          <p:cNvPr id="2" name="Text 1"/>
+          <p:cNvPr id="2" name="Text 0"/>
           <p:cNvSpPr/>
           <p:nvPr>
-            <p:ph idx="102" type="body" hasCustomPrompt="1"/>
+            <p:ph idx="101" type="body" hasCustomPrompt="1"/>
           </p:nvPr>
         </p:nvSpPr>
         <p:spPr>
@@ -8684,10 +8126,10 @@
       </p:sp>
       <p:sp>
         <p:nvSpPr>
-          <p:cNvPr id="3" name="Text 1"/>
+          <p:cNvPr id="3" name="Text 0"/>
           <p:cNvSpPr/>
           <p:nvPr>
-            <p:ph idx="103" type="title" hasCustomPrompt="1"/>
+            <p:ph idx="102" type="title" hasCustomPrompt="1"/>
           </p:nvPr>
         </p:nvSpPr>
         <p:spPr>
@@ -8731,7 +8173,7 @@
                 <a:ea typeface="Raleway" pitchFamily="34" charset="-122"/>
                 <a:cs typeface="Raleway" pitchFamily="34" charset="-120"/>
               </a:rPr>
-              <a:t>a saúde do seu município</a:t>
+              <a:t>a saúde do seu Município</a:t>
             </a:r>
             <a:endParaRPr lang="en-US" sz="3000" dirty="0"/>
           </a:p>
@@ -9846,54 +9288,6 @@
               <a:t>Desenvolve Consultoria Ltda. · CNPJ 27.594.121/0001-65 · Ribeirão Preto/SP</a:t>
             </a:r>
             <a:endParaRPr lang="en-US" sz="1000" dirty="0"/>
-          </a:p>
-        </p:txBody>
-      </p:sp>
-      <p:sp>
-        <p:nvSpPr>
-          <p:cNvPr id="25" name="Slide Number Placeholder 0"/>
-          <p:cNvSpPr>
-            <a:spLocks noGrp="1"/>
-          </p:cNvSpPr>
-          <p:nvPr>
-            <p:ph type="sldNum" sz="quarter" idx="4294967295"/>
-          </p:nvPr>
-        </p:nvSpPr>
-        <p:spPr>
-          <a:xfrm>
-            <a:off x="11155680" y="6355080"/>
-            <a:ext cx="502920" cy="274320"/>
-          </a:xfrm>
-          <a:prstGeom prst="rect">
-            <a:avLst/>
-          </a:prstGeom>
-          <a:extLst>
-            <a:ext uri="{C572A759-6A51-4108-AA02-DFA0A04FC94B}">
-              <ma14:wrappingTextBoxFlag xmlns:ma14="http://schemas.microsoft.com/office/mac/drawingml/2011/main" val="0"/>
-            </a:ext>
-          </a:extLst>
-        </p:spPr>
-        <p:txBody>
-          <a:bodyPr/>
-          <a:lstStyle>
-            <a:lvl1pPr>
-              <a:defRPr sz="1000">
-                <a:solidFill>
-                  <a:srgbClr val="4A5578"/>
-                </a:solidFill>
-                <a:latin typeface="Montserrat"/>
-                <a:ea typeface="Montserrat"/>
-                <a:cs typeface="Montserrat"/>
-              </a:defRPr>
-            </a:lvl1pPr>
-          </a:lstStyle>
-          <a:p>
-            <a:pPr algn="r"/>
-            <a:fld id="{F7021451-1387-4CA6-816F-3879F97B5CBC}" type="slidenum">
-              <a:rPr b="0" lang="en-US"/>
-              <a:t>9</a:t>
-            </a:fld>
-            <a:endParaRPr lang="en-US"/>
           </a:p>
         </p:txBody>
       </p:sp>

</xml_diff>